<commit_message>
Slides: per-slide key messages + analogy slide for non-DL readers (11 slides)
- every slide now carries a one-line takeaway message under the title
- new slide 5 "five designs by analogy": window inspectors (2021) ->
  better eyes (CNN bank) -> stenographer (SpinDETR) -> inspectors'
  meeting (PeriodFormer) -> meeting + surveyor (hybrid), each fixing
  the previous design's specific failure
- also adds paper-style architecture comparison figure
  (fig_arch_comparison.png/.pdf) and its generator script

Co-Authored-By: Claude Fable 5 <noreply@anthropic.com>
</commit_message>
<xml_diff>
--- a/results/NV_C13_hybrid_slides.pptx
+++ b/results/NV_C13_hybrid_slides.pptx
@@ -15,6 +15,7 @@
     <p:sldId id="263" r:id="rId14"/>
     <p:sldId id="264" r:id="rId15"/>
     <p:sldId id="265" r:id="rId16"/>
+    <p:sldId id="266" r:id="rId17"/>
   </p:sldIdLst>
   <p:sldSz cx="12191695" cy="6858000" type="screen4x3"/>
   <p:notesSz cx="6858000" cy="9144000"/>
@@ -3105,8 +3106,8 @@
         </p:nvSpPr>
         <p:spPr>
           <a:xfrm>
-            <a:off x="365760" y="137160"/>
-            <a:ext cx="11430000" cy="822960"/>
+            <a:off x="365760" y="109728"/>
+            <a:ext cx="11430000" cy="914400"/>
           </a:xfrm>
           <a:prstGeom prst="rect">
             <a:avLst/>
@@ -3120,7 +3121,7 @@
           <a:lstStyle/>
           <a:p>
             <a:pPr>
-              <a:defRPr sz="2800" b="1"/>
+              <a:defRPr sz="2600" b="1"/>
             </a:pPr>
             <a:r>
               <a:t>무엇을 했는가: 7단계 요약</a:t>
@@ -3128,10 +3129,22 @@
           </a:p>
           <a:p>
             <a:pPr>
-              <a:defRPr sz="1300"/>
+              <a:defRPr sz="1200"/>
             </a:pPr>
             <a:r>
               <a:t>물리 검증 → 2021 재구성 → ablation → 신규 모델 → 하이브리드 → 실측 GT 검증 → 실데이터 확정</a:t>
+            </a:r>
+          </a:p>
+          <a:p>
+            <a:pPr>
+              <a:defRPr sz="1400" b="1">
+                <a:solidFill>
+                  <a:srgbClr val="B45000"/>
+                </a:solidFill>
+              </a:defRPr>
+            </a:pPr>
+            <a:r>
+              <a:t>▶ 모든 주장 뒤에 검증 단계를 붙였다 — 마지막엔 정답을 아는 실측 스핀 환경으로 확인</a:t>
             </a:r>
           </a:p>
         </p:txBody>
@@ -3225,8 +3238,8 @@
         </p:nvSpPr>
         <p:spPr>
           <a:xfrm>
-            <a:off x="365760" y="137160"/>
-            <a:ext cx="11430000" cy="822960"/>
+            <a:off x="365760" y="109728"/>
+            <a:ext cx="11430000" cy="914400"/>
           </a:xfrm>
           <a:prstGeom prst="rect">
             <a:avLst/>
@@ -3240,18 +3253,2115 @@
           <a:lstStyle/>
           <a:p>
             <a:pPr>
-              <a:defRPr sz="2800" b="1"/>
+              <a:defRPr sz="2600" b="1"/>
             </a:pPr>
             <a:r>
+              <a:t>NV1: 알고리즘별 A-텐서 값 종합표</a:t>
+            </a:r>
+          </a:p>
+          <a:p>
+            <a:pPr>
+              <a:defRPr sz="1200"/>
+            </a:pPr>
+            <a:r>
+              <a:t>값 = (A∥, A⊥) kHz · 윈도우뱅크/PF는 A 위치만 출력 · *앵커 부호는 m_s 브랜치 관례 차이</a:t>
+            </a:r>
+          </a:p>
+          <a:p>
+            <a:pPr>
+              <a:defRPr sz="1400" b="1">
+                <a:solidFill>
+                  <a:srgbClr val="B45000"/>
+                </a:solidFill>
+              </a:defRPr>
+            </a:pPr>
+            <a:r>
+              <a:t>▶ 핵심 스핀 4개는 9개 방법 전원 일치 — 방법을 바꿔도 같은 답이 나온다</a:t>
+            </a:r>
+          </a:p>
+        </p:txBody>
+      </p:sp>
+      <p:graphicFrame>
+        <p:nvGraphicFramePr>
+          <p:cNvPr id="3" name="Table 2"/>
+          <p:cNvGraphicFramePr>
+            <a:graphicFrameLocks noGrp="1"/>
+          </p:cNvGraphicFramePr>
+          <p:nvPr/>
+        </p:nvGraphicFramePr>
+        <p:xfrm>
+          <a:off x="274320" y="1143000"/>
+          <a:ext cx="11658600" cy="5394960"/>
+        </p:xfrm>
+        <a:graphic>
+          <a:graphicData uri="http://schemas.openxmlformats.org/drawingml/2006/table">
+            <a:tbl>
+              <a:tblPr firstRow="1" bandRow="1">
+                <a:tableStyleId>{5C22544A-7EE6-4342-B048-85BDC9FD1C3A}</a:tableStyleId>
+              </a:tblPr>
+              <a:tblGrid>
+                <a:gridCol w="1457325"/>
+                <a:gridCol w="1457325"/>
+                <a:gridCol w="1457325"/>
+                <a:gridCol w="1457325"/>
+                <a:gridCol w="1457325"/>
+                <a:gridCol w="1457325"/>
+                <a:gridCol w="1457325"/>
+                <a:gridCol w="1457325"/>
+              </a:tblGrid>
+              <a:tr h="337185">
+                <a:tc>
+                  <a:txBody>
+                    <a:bodyPr/>
+                    <a:lstStyle/>
+                    <a:p>
+                      <a:pPr>
+                        <a:defRPr sz="900" b="1"/>
+                      </a:pPr>
+                      <a:r>
+                        <a:t>앙상블 최종</a:t>
+                      </a:r>
+                    </a:p>
+                  </a:txBody>
+                  <a:tcPr>
+                    <a:solidFill>
+                      <a:srgbClr val="F4CCCC"/>
+                    </a:solidFill>
+                  </a:tcPr>
+                </a:tc>
+                <a:tc>
+                  <a:txBody>
+                    <a:bodyPr/>
+                    <a:lstStyle/>
+                    <a:p>
+                      <a:pPr>
+                        <a:defRPr sz="900" b="1"/>
+                      </a:pPr>
+                      <a:r>
+                        <a:t>ppt 앵커</a:t>
+                      </a:r>
+                    </a:p>
+                  </a:txBody>
+                  <a:tcPr>
+                    <a:solidFill>
+                      <a:srgbClr val="FCE5CD"/>
+                    </a:solidFill>
+                  </a:tcPr>
+                </a:tc>
+                <a:tc>
+                  <a:txBody>
+                    <a:bodyPr/>
+                    <a:lstStyle/>
+                    <a:p>
+                      <a:pPr>
+                        <a:defRPr sz="900" b="1"/>
+                      </a:pPr>
+                      <a:r>
+                        <a:t>2021-MLP</a:t>
+                      </a:r>
+                    </a:p>
+                  </a:txBody>
+                  <a:tcPr>
+                    <a:solidFill>
+                      <a:srgbClr val="D9D9D9"/>
+                    </a:solidFill>
+                  </a:tcPr>
+                </a:tc>
+                <a:tc>
+                  <a:txBody>
+                    <a:bodyPr/>
+                    <a:lstStyle/>
+                    <a:p>
+                      <a:pPr>
+                        <a:defRPr sz="900" b="1"/>
+                      </a:pPr>
+                      <a:r>
+                        <a:t>CNN뱅크</a:t>
+                      </a:r>
+                    </a:p>
+                  </a:txBody>
+                  <a:tcPr>
+                    <a:solidFill>
+                      <a:srgbClr val="D9D9D9"/>
+                    </a:solidFill>
+                  </a:tcPr>
+                </a:tc>
+                <a:tc>
+                  <a:txBody>
+                    <a:bodyPr/>
+                    <a:lstStyle/>
+                    <a:p>
+                      <a:pPr>
+                        <a:defRPr sz="900" b="1"/>
+                      </a:pPr>
+                      <a:r>
+                        <a:t>PF</a:t>
+                      </a:r>
+                    </a:p>
+                  </a:txBody>
+                  <a:tcPr>
+                    <a:solidFill>
+                      <a:srgbClr val="D9D9D9"/>
+                    </a:solidFill>
+                  </a:tcPr>
+                </a:tc>
+                <a:tc>
+                  <a:txBody>
+                    <a:bodyPr/>
+                    <a:lstStyle/>
+                    <a:p>
+                      <a:pPr>
+                        <a:defRPr sz="900" b="1"/>
+                      </a:pPr>
+                      <a:r>
+                        <a:t>SpinDETR</a:t>
+                      </a:r>
+                    </a:p>
+                  </a:txBody>
+                  <a:tcPr>
+                    <a:solidFill>
+                      <a:srgbClr val="D9EAD3"/>
+                    </a:solidFill>
+                  </a:tcPr>
+                </a:tc>
+                <a:tc>
+                  <a:txBody>
+                    <a:bodyPr/>
+                    <a:lstStyle/>
+                    <a:p>
+                      <a:pPr>
+                        <a:defRPr sz="900" b="1"/>
+                      </a:pPr>
+                      <a:r>
+                        <a:t>cdetect-DE</a:t>
+                      </a:r>
+                    </a:p>
+                  </a:txBody>
+                  <a:tcPr>
+                    <a:solidFill>
+                      <a:srgbClr val="CFE2F3"/>
+                    </a:solidFill>
+                  </a:tcPr>
+                </a:tc>
+                <a:tc>
+                  <a:txBody>
+                    <a:bodyPr/>
+                    <a:lstStyle/>
+                    <a:p>
+                      <a:pPr>
+                        <a:defRPr sz="900" b="1"/>
+                      </a:pPr>
+                      <a:r>
+                        <a:t>하이브리드</a:t>
+                      </a:r>
+                    </a:p>
+                  </a:txBody>
+                  <a:tcPr>
+                    <a:solidFill>
+                      <a:srgbClr val="EAD1DC"/>
+                    </a:solidFill>
+                  </a:tcPr>
+                </a:tc>
+              </a:tr>
+              <a:tr h="337185">
+                <a:tc>
+                  <a:txBody>
+                    <a:bodyPr/>
+                    <a:lstStyle/>
+                    <a:p>
+                      <a:pPr>
+                        <a:defRPr sz="900" b="1"/>
+                      </a:pPr>
+                      <a:r>
+                        <a:t>(−87.9, 18)</a:t>
+                      </a:r>
+                    </a:p>
+                  </a:txBody>
+                  <a:tcPr/>
+                </a:tc>
+                <a:tc>
+                  <a:txBody>
+                    <a:bodyPr/>
+                    <a:lstStyle/>
+                    <a:p>
+                      <a:pPr>
+                        <a:defRPr sz="900"/>
+                      </a:pPr>
+                      <a:r>
+                        <a:t>(−88, 47)</a:t>
+                      </a:r>
+                    </a:p>
+                  </a:txBody>
+                  <a:tcPr/>
+                </a:tc>
+                <a:tc>
+                  <a:txBody>
+                    <a:bodyPr/>
+                    <a:lstStyle/>
+                    <a:p>
+                      <a:pPr>
+                        <a:defRPr sz="900"/>
+                      </a:pPr>
+                      <a:r>
+                        <a:t>—</a:t>
+                      </a:r>
+                    </a:p>
+                  </a:txBody>
+                  <a:tcPr/>
+                </a:tc>
+                <a:tc>
+                  <a:txBody>
+                    <a:bodyPr/>
+                    <a:lstStyle/>
+                    <a:p>
+                      <a:pPr>
+                        <a:defRPr sz="900"/>
+                      </a:pPr>
+                      <a:r>
+                        <a:t>—</a:t>
+                      </a:r>
+                    </a:p>
+                  </a:txBody>
+                  <a:tcPr/>
+                </a:tc>
+                <a:tc>
+                  <a:txBody>
+                    <a:bodyPr/>
+                    <a:lstStyle/>
+                    <a:p>
+                      <a:pPr>
+                        <a:defRPr sz="900"/>
+                      </a:pPr>
+                      <a:r>
+                        <a:t>−86</a:t>
+                      </a:r>
+                    </a:p>
+                  </a:txBody>
+                  <a:tcPr/>
+                </a:tc>
+                <a:tc>
+                  <a:txBody>
+                    <a:bodyPr/>
+                    <a:lstStyle/>
+                    <a:p>
+                      <a:pPr>
+                        <a:defRPr sz="900"/>
+                      </a:pPr>
+                      <a:r>
+                        <a:t>—</a:t>
+                      </a:r>
+                    </a:p>
+                  </a:txBody>
+                  <a:tcPr/>
+                </a:tc>
+                <a:tc>
+                  <a:txBody>
+                    <a:bodyPr/>
+                    <a:lstStyle/>
+                    <a:p>
+                      <a:pPr>
+                        <a:defRPr sz="900"/>
+                      </a:pPr>
+                      <a:r>
+                        <a:t>(−87.6, 19)</a:t>
+                      </a:r>
+                    </a:p>
+                  </a:txBody>
+                  <a:tcPr/>
+                </a:tc>
+                <a:tc>
+                  <a:txBody>
+                    <a:bodyPr/>
+                    <a:lstStyle/>
+                    <a:p>
+                      <a:pPr>
+                        <a:defRPr sz="900"/>
+                      </a:pPr>
+                      <a:r>
+                        <a:t>—</a:t>
+                      </a:r>
+                    </a:p>
+                  </a:txBody>
+                  <a:tcPr/>
+                </a:tc>
+              </a:tr>
+              <a:tr h="337185">
+                <a:tc>
+                  <a:txBody>
+                    <a:bodyPr/>
+                    <a:lstStyle/>
+                    <a:p>
+                      <a:pPr>
+                        <a:defRPr sz="900" b="1"/>
+                      </a:pPr>
+                      <a:r>
+                        <a:t>(−18.8, 16)</a:t>
+                      </a:r>
+                    </a:p>
+                  </a:txBody>
+                  <a:tcPr/>
+                </a:tc>
+                <a:tc>
+                  <a:txBody>
+                    <a:bodyPr/>
+                    <a:lstStyle/>
+                    <a:p>
+                      <a:pPr>
+                        <a:defRPr sz="900"/>
+                      </a:pPr>
+                      <a:r>
+                        <a:t>—</a:t>
+                      </a:r>
+                    </a:p>
+                  </a:txBody>
+                  <a:tcPr/>
+                </a:tc>
+                <a:tc>
+                  <a:txBody>
+                    <a:bodyPr/>
+                    <a:lstStyle/>
+                    <a:p>
+                      <a:pPr>
+                        <a:defRPr sz="900"/>
+                      </a:pPr>
+                      <a:r>
+                        <a:t>−20</a:t>
+                      </a:r>
+                    </a:p>
+                  </a:txBody>
+                  <a:tcPr/>
+                </a:tc>
+                <a:tc>
+                  <a:txBody>
+                    <a:bodyPr/>
+                    <a:lstStyle/>
+                    <a:p>
+                      <a:pPr>
+                        <a:defRPr sz="900"/>
+                      </a:pPr>
+                      <a:r>
+                        <a:t>−16</a:t>
+                      </a:r>
+                    </a:p>
+                  </a:txBody>
+                  <a:tcPr/>
+                </a:tc>
+                <a:tc>
+                  <a:txBody>
+                    <a:bodyPr/>
+                    <a:lstStyle/>
+                    <a:p>
+                      <a:pPr>
+                        <a:defRPr sz="900"/>
+                      </a:pPr>
+                      <a:r>
+                        <a:t>−16</a:t>
+                      </a:r>
+                    </a:p>
+                  </a:txBody>
+                  <a:tcPr/>
+                </a:tc>
+                <a:tc>
+                  <a:txBody>
+                    <a:bodyPr/>
+                    <a:lstStyle/>
+                    <a:p>
+                      <a:pPr>
+                        <a:defRPr sz="900"/>
+                      </a:pPr>
+                      <a:r>
+                        <a:t>(−15.5, 21)</a:t>
+                      </a:r>
+                    </a:p>
+                  </a:txBody>
+                  <a:tcPr/>
+                </a:tc>
+                <a:tc>
+                  <a:txBody>
+                    <a:bodyPr/>
+                    <a:lstStyle/>
+                    <a:p>
+                      <a:pPr>
+                        <a:defRPr sz="900"/>
+                      </a:pPr>
+                      <a:r>
+                        <a:t>—</a:t>
+                      </a:r>
+                    </a:p>
+                  </a:txBody>
+                  <a:tcPr/>
+                </a:tc>
+                <a:tc>
+                  <a:txBody>
+                    <a:bodyPr/>
+                    <a:lstStyle/>
+                    <a:p>
+                      <a:pPr>
+                        <a:defRPr sz="900"/>
+                      </a:pPr>
+                      <a:r>
+                        <a:t>(−19.0, 16)</a:t>
+                      </a:r>
+                    </a:p>
+                  </a:txBody>
+                  <a:tcPr/>
+                </a:tc>
+              </a:tr>
+              <a:tr h="337185">
+                <a:tc>
+                  <a:txBody>
+                    <a:bodyPr/>
+                    <a:lstStyle/>
+                    <a:p>
+                      <a:pPr>
+                        <a:defRPr sz="900" b="1"/>
+                      </a:pPr>
+                      <a:r>
+                        <a:t>(−11.5, 14)</a:t>
+                      </a:r>
+                    </a:p>
+                  </a:txBody>
+                  <a:tcPr/>
+                </a:tc>
+                <a:tc>
+                  <a:txBody>
+                    <a:bodyPr/>
+                    <a:lstStyle/>
+                    <a:p>
+                      <a:pPr>
+                        <a:defRPr sz="900"/>
+                      </a:pPr>
+                      <a:r>
+                        <a:t>—</a:t>
+                      </a:r>
+                    </a:p>
+                  </a:txBody>
+                  <a:tcPr/>
+                </a:tc>
+                <a:tc>
+                  <a:txBody>
+                    <a:bodyPr/>
+                    <a:lstStyle/>
+                    <a:p>
+                      <a:pPr>
+                        <a:defRPr sz="900"/>
+                      </a:pPr>
+                      <a:r>
+                        <a:t>—</a:t>
+                      </a:r>
+                    </a:p>
+                  </a:txBody>
+                  <a:tcPr/>
+                </a:tc>
+                <a:tc>
+                  <a:txBody>
+                    <a:bodyPr/>
+                    <a:lstStyle/>
+                    <a:p>
+                      <a:pPr>
+                        <a:defRPr sz="900"/>
+                      </a:pPr>
+                      <a:r>
+                        <a:t>−8</a:t>
+                      </a:r>
+                    </a:p>
+                  </a:txBody>
+                  <a:tcPr/>
+                </a:tc>
+                <a:tc>
+                  <a:txBody>
+                    <a:bodyPr/>
+                    <a:lstStyle/>
+                    <a:p>
+                      <a:pPr>
+                        <a:defRPr sz="900"/>
+                      </a:pPr>
+                      <a:r>
+                        <a:t>—</a:t>
+                      </a:r>
+                    </a:p>
+                  </a:txBody>
+                  <a:tcPr/>
+                </a:tc>
+                <a:tc>
+                  <a:txBody>
+                    <a:bodyPr/>
+                    <a:lstStyle/>
+                    <a:p>
+                      <a:pPr>
+                        <a:defRPr sz="900"/>
+                      </a:pPr>
+                      <a:r>
+                        <a:t>—</a:t>
+                      </a:r>
+                    </a:p>
+                  </a:txBody>
+                  <a:tcPr/>
+                </a:tc>
+                <a:tc>
+                  <a:txBody>
+                    <a:bodyPr/>
+                    <a:lstStyle/>
+                    <a:p>
+                      <a:pPr>
+                        <a:defRPr sz="900"/>
+                      </a:pPr>
+                      <a:r>
+                        <a:t>—</a:t>
+                      </a:r>
+                    </a:p>
+                  </a:txBody>
+                  <a:tcPr/>
+                </a:tc>
+                <a:tc>
+                  <a:txBody>
+                    <a:bodyPr/>
+                    <a:lstStyle/>
+                    <a:p>
+                      <a:pPr>
+                        <a:defRPr sz="900"/>
+                      </a:pPr>
+                      <a:r>
+                        <a:t>(−13.9, 16)</a:t>
+                      </a:r>
+                    </a:p>
+                  </a:txBody>
+                  <a:tcPr/>
+                </a:tc>
+              </a:tr>
+              <a:tr h="337185">
+                <a:tc>
+                  <a:txBody>
+                    <a:bodyPr/>
+                    <a:lstStyle/>
+                    <a:p>
+                      <a:pPr>
+                        <a:defRPr sz="900" b="1"/>
+                      </a:pPr>
+                      <a:r>
+                        <a:t>(−5.1, 22)</a:t>
+                      </a:r>
+                    </a:p>
+                  </a:txBody>
+                  <a:tcPr/>
+                </a:tc>
+                <a:tc>
+                  <a:txBody>
+                    <a:bodyPr/>
+                    <a:lstStyle/>
+                    <a:p>
+                      <a:pPr>
+                        <a:defRPr sz="900"/>
+                      </a:pPr>
+                      <a:r>
+                        <a:t>(−5, 35)</a:t>
+                      </a:r>
+                    </a:p>
+                  </a:txBody>
+                  <a:tcPr/>
+                </a:tc>
+                <a:tc>
+                  <a:txBody>
+                    <a:bodyPr/>
+                    <a:lstStyle/>
+                    <a:p>
+                      <a:pPr>
+                        <a:defRPr sz="900"/>
+                      </a:pPr>
+                      <a:r>
+                        <a:t>−6</a:t>
+                      </a:r>
+                    </a:p>
+                  </a:txBody>
+                  <a:tcPr/>
+                </a:tc>
+                <a:tc>
+                  <a:txBody>
+                    <a:bodyPr/>
+                    <a:lstStyle/>
+                    <a:p>
+                      <a:pPr>
+                        <a:defRPr sz="900"/>
+                      </a:pPr>
+                      <a:r>
+                        <a:t>−8</a:t>
+                      </a:r>
+                    </a:p>
+                  </a:txBody>
+                  <a:tcPr/>
+                </a:tc>
+                <a:tc>
+                  <a:txBody>
+                    <a:bodyPr/>
+                    <a:lstStyle/>
+                    <a:p>
+                      <a:pPr>
+                        <a:defRPr sz="900"/>
+                      </a:pPr>
+                      <a:r>
+                        <a:t>−6</a:t>
+                      </a:r>
+                    </a:p>
+                  </a:txBody>
+                  <a:tcPr/>
+                </a:tc>
+                <a:tc>
+                  <a:txBody>
+                    <a:bodyPr/>
+                    <a:lstStyle/>
+                    <a:p>
+                      <a:pPr>
+                        <a:defRPr sz="900"/>
+                      </a:pPr>
+                      <a:r>
+                        <a:t>(−6.2, 29)</a:t>
+                      </a:r>
+                    </a:p>
+                  </a:txBody>
+                  <a:tcPr/>
+                </a:tc>
+                <a:tc>
+                  <a:txBody>
+                    <a:bodyPr/>
+                    <a:lstStyle/>
+                    <a:p>
+                      <a:pPr>
+                        <a:defRPr sz="900"/>
+                      </a:pPr>
+                      <a:r>
+                        <a:t>(−5.6, 26)</a:t>
+                      </a:r>
+                    </a:p>
+                  </a:txBody>
+                  <a:tcPr/>
+                </a:tc>
+                <a:tc>
+                  <a:txBody>
+                    <a:bodyPr/>
+                    <a:lstStyle/>
+                    <a:p>
+                      <a:pPr>
+                        <a:defRPr sz="900"/>
+                      </a:pPr>
+                      <a:r>
+                        <a:t>(−5.1, 23)</a:t>
+                      </a:r>
+                    </a:p>
+                  </a:txBody>
+                  <a:tcPr/>
+                </a:tc>
+              </a:tr>
+              <a:tr h="337185">
+                <a:tc>
+                  <a:txBody>
+                    <a:bodyPr/>
+                    <a:lstStyle/>
+                    <a:p>
+                      <a:pPr>
+                        <a:defRPr sz="900" b="1"/>
+                      </a:pPr>
+                      <a:r>
+                        <a:t>(+0.6, 17)</a:t>
+                      </a:r>
+                    </a:p>
+                  </a:txBody>
+                  <a:tcPr/>
+                </a:tc>
+                <a:tc>
+                  <a:txBody>
+                    <a:bodyPr/>
+                    <a:lstStyle/>
+                    <a:p>
+                      <a:pPr>
+                        <a:defRPr sz="900"/>
+                      </a:pPr>
+                      <a:r>
+                        <a:t>—</a:t>
+                      </a:r>
+                    </a:p>
+                  </a:txBody>
+                  <a:tcPr/>
+                </a:tc>
+                <a:tc>
+                  <a:txBody>
+                    <a:bodyPr/>
+                    <a:lstStyle/>
+                    <a:p>
+                      <a:pPr>
+                        <a:defRPr sz="900"/>
+                      </a:pPr>
+                      <a:r>
+                        <a:t>+2</a:t>
+                      </a:r>
+                    </a:p>
+                  </a:txBody>
+                  <a:tcPr/>
+                </a:tc>
+                <a:tc>
+                  <a:txBody>
+                    <a:bodyPr/>
+                    <a:lstStyle/>
+                    <a:p>
+                      <a:pPr>
+                        <a:defRPr sz="900"/>
+                      </a:pPr>
+                      <a:r>
+                        <a:t>—</a:t>
+                      </a:r>
+                    </a:p>
+                  </a:txBody>
+                  <a:tcPr/>
+                </a:tc>
+                <a:tc>
+                  <a:txBody>
+                    <a:bodyPr/>
+                    <a:lstStyle/>
+                    <a:p>
+                      <a:pPr>
+                        <a:defRPr sz="900"/>
+                      </a:pPr>
+                      <a:r>
+                        <a:t>+2</a:t>
+                      </a:r>
+                    </a:p>
+                  </a:txBody>
+                  <a:tcPr/>
+                </a:tc>
+                <a:tc>
+                  <a:txBody>
+                    <a:bodyPr/>
+                    <a:lstStyle/>
+                    <a:p>
+                      <a:pPr>
+                        <a:defRPr sz="900"/>
+                      </a:pPr>
+                      <a:r>
+                        <a:t>(−2.2, 23)</a:t>
+                      </a:r>
+                    </a:p>
+                  </a:txBody>
+                  <a:tcPr/>
+                </a:tc>
+                <a:tc>
+                  <a:txBody>
+                    <a:bodyPr/>
+                    <a:lstStyle/>
+                    <a:p>
+                      <a:pPr>
+                        <a:defRPr sz="900"/>
+                      </a:pPr>
+                      <a:r>
+                        <a:t>(+3.3, 30)</a:t>
+                      </a:r>
+                    </a:p>
+                  </a:txBody>
+                  <a:tcPr/>
+                </a:tc>
+                <a:tc>
+                  <a:txBody>
+                    <a:bodyPr/>
+                    <a:lstStyle/>
+                    <a:p>
+                      <a:pPr>
+                        <a:defRPr sz="900"/>
+                      </a:pPr>
+                      <a:r>
+                        <a:t>(+1.1, 21)</a:t>
+                      </a:r>
+                    </a:p>
+                  </a:txBody>
+                  <a:tcPr/>
+                </a:tc>
+              </a:tr>
+              <a:tr h="337185">
+                <a:tc>
+                  <a:txBody>
+                    <a:bodyPr/>
+                    <a:lstStyle/>
+                    <a:p>
+                      <a:pPr>
+                        <a:defRPr sz="900" b="1"/>
+                      </a:pPr>
+                      <a:r>
+                        <a:t>(+4.0, 26)</a:t>
+                      </a:r>
+                    </a:p>
+                  </a:txBody>
+                  <a:tcPr/>
+                </a:tc>
+                <a:tc>
+                  <a:txBody>
+                    <a:bodyPr/>
+                    <a:lstStyle/>
+                    <a:p>
+                      <a:pPr>
+                        <a:defRPr sz="900"/>
+                      </a:pPr>
+                      <a:r>
+                        <a:t>—</a:t>
+                      </a:r>
+                    </a:p>
+                  </a:txBody>
+                  <a:tcPr/>
+                </a:tc>
+                <a:tc>
+                  <a:txBody>
+                    <a:bodyPr/>
+                    <a:lstStyle/>
+                    <a:p>
+                      <a:pPr>
+                        <a:defRPr sz="900"/>
+                      </a:pPr>
+                      <a:r>
+                        <a:t>+2</a:t>
+                      </a:r>
+                    </a:p>
+                  </a:txBody>
+                  <a:tcPr/>
+                </a:tc>
+                <a:tc>
+                  <a:txBody>
+                    <a:bodyPr/>
+                    <a:lstStyle/>
+                    <a:p>
+                      <a:pPr>
+                        <a:defRPr sz="900"/>
+                      </a:pPr>
+                      <a:r>
+                        <a:t>+4</a:t>
+                      </a:r>
+                    </a:p>
+                  </a:txBody>
+                  <a:tcPr/>
+                </a:tc>
+                <a:tc>
+                  <a:txBody>
+                    <a:bodyPr/>
+                    <a:lstStyle/>
+                    <a:p>
+                      <a:pPr>
+                        <a:defRPr sz="900"/>
+                      </a:pPr>
+                      <a:r>
+                        <a:t>+2</a:t>
+                      </a:r>
+                    </a:p>
+                  </a:txBody>
+                  <a:tcPr/>
+                </a:tc>
+                <a:tc>
+                  <a:txBody>
+                    <a:bodyPr/>
+                    <a:lstStyle/>
+                    <a:p>
+                      <a:pPr>
+                        <a:defRPr sz="900"/>
+                      </a:pPr>
+                      <a:r>
+                        <a:t>—</a:t>
+                      </a:r>
+                    </a:p>
+                  </a:txBody>
+                  <a:tcPr/>
+                </a:tc>
+                <a:tc>
+                  <a:txBody>
+                    <a:bodyPr/>
+                    <a:lstStyle/>
+                    <a:p>
+                      <a:pPr>
+                        <a:defRPr sz="900"/>
+                      </a:pPr>
+                      <a:r>
+                        <a:t>(+3.3, 30)</a:t>
+                      </a:r>
+                    </a:p>
+                  </a:txBody>
+                  <a:tcPr/>
+                </a:tc>
+                <a:tc>
+                  <a:txBody>
+                    <a:bodyPr/>
+                    <a:lstStyle/>
+                    <a:p>
+                      <a:pPr>
+                        <a:defRPr sz="900"/>
+                      </a:pPr>
+                      <a:r>
+                        <a:t>(+4.0, 27)</a:t>
+                      </a:r>
+                    </a:p>
+                  </a:txBody>
+                  <a:tcPr/>
+                </a:tc>
+              </a:tr>
+              <a:tr h="337185">
+                <a:tc>
+                  <a:txBody>
+                    <a:bodyPr/>
+                    <a:lstStyle/>
+                    <a:p>
+                      <a:pPr>
+                        <a:defRPr sz="900" b="1"/>
+                      </a:pPr>
+                      <a:r>
+                        <a:t>(+8.4, 28)</a:t>
+                      </a:r>
+                    </a:p>
+                  </a:txBody>
+                  <a:tcPr/>
+                </a:tc>
+                <a:tc>
+                  <a:txBody>
+                    <a:bodyPr/>
+                    <a:lstStyle/>
+                    <a:p>
+                      <a:pPr>
+                        <a:defRPr sz="900"/>
+                      </a:pPr>
+                      <a:r>
+                        <a:t>(+8, 31)</a:t>
+                      </a:r>
+                    </a:p>
+                  </a:txBody>
+                  <a:tcPr/>
+                </a:tc>
+                <a:tc>
+                  <a:txBody>
+                    <a:bodyPr/>
+                    <a:lstStyle/>
+                    <a:p>
+                      <a:pPr>
+                        <a:defRPr sz="900"/>
+                      </a:pPr>
+                      <a:r>
+                        <a:t>+12</a:t>
+                      </a:r>
+                    </a:p>
+                  </a:txBody>
+                  <a:tcPr/>
+                </a:tc>
+                <a:tc>
+                  <a:txBody>
+                    <a:bodyPr/>
+                    <a:lstStyle/>
+                    <a:p>
+                      <a:pPr>
+                        <a:defRPr sz="900"/>
+                      </a:pPr>
+                      <a:r>
+                        <a:t>+4</a:t>
+                      </a:r>
+                    </a:p>
+                  </a:txBody>
+                  <a:tcPr/>
+                </a:tc>
+                <a:tc>
+                  <a:txBody>
+                    <a:bodyPr/>
+                    <a:lstStyle/>
+                    <a:p>
+                      <a:pPr>
+                        <a:defRPr sz="900"/>
+                      </a:pPr>
+                      <a:r>
+                        <a:t>+8</a:t>
+                      </a:r>
+                    </a:p>
+                  </a:txBody>
+                  <a:tcPr/>
+                </a:tc>
+                <a:tc>
+                  <a:txBody>
+                    <a:bodyPr/>
+                    <a:lstStyle/>
+                    <a:p>
+                      <a:pPr>
+                        <a:defRPr sz="900"/>
+                      </a:pPr>
+                      <a:r>
+                        <a:t>(+7.4, 29)</a:t>
+                      </a:r>
+                    </a:p>
+                  </a:txBody>
+                  <a:tcPr/>
+                </a:tc>
+                <a:tc>
+                  <a:txBody>
+                    <a:bodyPr/>
+                    <a:lstStyle/>
+                    <a:p>
+                      <a:pPr>
+                        <a:defRPr sz="900"/>
+                      </a:pPr>
+                      <a:r>
+                        <a:t>(+9.2, 31)</a:t>
+                      </a:r>
+                    </a:p>
+                  </a:txBody>
+                  <a:tcPr/>
+                </a:tc>
+                <a:tc>
+                  <a:txBody>
+                    <a:bodyPr/>
+                    <a:lstStyle/>
+                    <a:p>
+                      <a:pPr>
+                        <a:defRPr sz="900"/>
+                      </a:pPr>
+                      <a:r>
+                        <a:t>(+8.5, 30)</a:t>
+                      </a:r>
+                    </a:p>
+                  </a:txBody>
+                  <a:tcPr/>
+                </a:tc>
+              </a:tr>
+              <a:tr h="337185">
+                <a:tc>
+                  <a:txBody>
+                    <a:bodyPr/>
+                    <a:lstStyle/>
+                    <a:p>
+                      <a:pPr>
+                        <a:defRPr sz="900" b="1"/>
+                      </a:pPr>
+                      <a:r>
+                        <a:t>(+14.2, 22)</a:t>
+                      </a:r>
+                    </a:p>
+                  </a:txBody>
+                  <a:tcPr/>
+                </a:tc>
+                <a:tc>
+                  <a:txBody>
+                    <a:bodyPr/>
+                    <a:lstStyle/>
+                    <a:p>
+                      <a:pPr>
+                        <a:defRPr sz="900"/>
+                      </a:pPr>
+                      <a:r>
+                        <a:t>—</a:t>
+                      </a:r>
+                    </a:p>
+                  </a:txBody>
+                  <a:tcPr/>
+                </a:tc>
+                <a:tc>
+                  <a:txBody>
+                    <a:bodyPr/>
+                    <a:lstStyle/>
+                    <a:p>
+                      <a:pPr>
+                        <a:defRPr sz="900"/>
+                      </a:pPr>
+                      <a:r>
+                        <a:t>+12</a:t>
+                      </a:r>
+                    </a:p>
+                  </a:txBody>
+                  <a:tcPr/>
+                </a:tc>
+                <a:tc>
+                  <a:txBody>
+                    <a:bodyPr/>
+                    <a:lstStyle/>
+                    <a:p>
+                      <a:pPr>
+                        <a:defRPr sz="900"/>
+                      </a:pPr>
+                      <a:r>
+                        <a:t>—</a:t>
+                      </a:r>
+                    </a:p>
+                  </a:txBody>
+                  <a:tcPr/>
+                </a:tc>
+                <a:tc>
+                  <a:txBody>
+                    <a:bodyPr/>
+                    <a:lstStyle/>
+                    <a:p>
+                      <a:pPr>
+                        <a:defRPr sz="900"/>
+                      </a:pPr>
+                      <a:r>
+                        <a:t>+14</a:t>
+                      </a:r>
+                    </a:p>
+                  </a:txBody>
+                  <a:tcPr/>
+                </a:tc>
+                <a:tc>
+                  <a:txBody>
+                    <a:bodyPr/>
+                    <a:lstStyle/>
+                    <a:p>
+                      <a:pPr>
+                        <a:defRPr sz="900"/>
+                      </a:pPr>
+                      <a:r>
+                        <a:t>(+13.1, 25)</a:t>
+                      </a:r>
+                    </a:p>
+                  </a:txBody>
+                  <a:tcPr/>
+                </a:tc>
+                <a:tc>
+                  <a:txBody>
+                    <a:bodyPr/>
+                    <a:lstStyle/>
+                    <a:p>
+                      <a:pPr>
+                        <a:defRPr sz="900"/>
+                      </a:pPr>
+                      <a:r>
+                        <a:t>—</a:t>
+                      </a:r>
+                    </a:p>
+                  </a:txBody>
+                  <a:tcPr/>
+                </a:tc>
+                <a:tc>
+                  <a:txBody>
+                    <a:bodyPr/>
+                    <a:lstStyle/>
+                    <a:p>
+                      <a:pPr>
+                        <a:defRPr sz="900"/>
+                      </a:pPr>
+                      <a:r>
+                        <a:t>(+14.5, 25)</a:t>
+                      </a:r>
+                    </a:p>
+                  </a:txBody>
+                  <a:tcPr/>
+                </a:tc>
+              </a:tr>
+              <a:tr h="337185">
+                <a:tc>
+                  <a:txBody>
+                    <a:bodyPr/>
+                    <a:lstStyle/>
+                    <a:p>
+                      <a:pPr>
+                        <a:defRPr sz="900" b="1"/>
+                      </a:pPr>
+                      <a:r>
+                        <a:t>(+24.3, 20)</a:t>
+                      </a:r>
+                    </a:p>
+                  </a:txBody>
+                  <a:tcPr/>
+                </a:tc>
+                <a:tc>
+                  <a:txBody>
+                    <a:bodyPr/>
+                    <a:lstStyle/>
+                    <a:p>
+                      <a:pPr>
+                        <a:defRPr sz="900"/>
+                      </a:pPr>
+                      <a:r>
+                        <a:t>—</a:t>
+                      </a:r>
+                    </a:p>
+                  </a:txBody>
+                  <a:tcPr/>
+                </a:tc>
+                <a:tc>
+                  <a:txBody>
+                    <a:bodyPr/>
+                    <a:lstStyle/>
+                    <a:p>
+                      <a:pPr>
+                        <a:defRPr sz="900"/>
+                      </a:pPr>
+                      <a:r>
+                        <a:t>+22</a:t>
+                      </a:r>
+                    </a:p>
+                  </a:txBody>
+                  <a:tcPr/>
+                </a:tc>
+                <a:tc>
+                  <a:txBody>
+                    <a:bodyPr/>
+                    <a:lstStyle/>
+                    <a:p>
+                      <a:pPr>
+                        <a:defRPr sz="900"/>
+                      </a:pPr>
+                      <a:r>
+                        <a:t>+28</a:t>
+                      </a:r>
+                    </a:p>
+                  </a:txBody>
+                  <a:tcPr/>
+                </a:tc>
+                <a:tc>
+                  <a:txBody>
+                    <a:bodyPr/>
+                    <a:lstStyle/>
+                    <a:p>
+                      <a:pPr>
+                        <a:defRPr sz="900"/>
+                      </a:pPr>
+                      <a:r>
+                        <a:t>+22</a:t>
+                      </a:r>
+                    </a:p>
+                  </a:txBody>
+                  <a:tcPr/>
+                </a:tc>
+                <a:tc>
+                  <a:txBody>
+                    <a:bodyPr/>
+                    <a:lstStyle/>
+                    <a:p>
+                      <a:pPr>
+                        <a:defRPr sz="900"/>
+                      </a:pPr>
+                      <a:r>
+                        <a:t>—</a:t>
+                      </a:r>
+                    </a:p>
+                  </a:txBody>
+                  <a:tcPr/>
+                </a:tc>
+                <a:tc>
+                  <a:txBody>
+                    <a:bodyPr/>
+                    <a:lstStyle/>
+                    <a:p>
+                      <a:pPr>
+                        <a:defRPr sz="900"/>
+                      </a:pPr>
+                      <a:r>
+                        <a:t>(+23.7, 24)</a:t>
+                      </a:r>
+                    </a:p>
+                  </a:txBody>
+                  <a:tcPr/>
+                </a:tc>
+                <a:tc>
+                  <a:txBody>
+                    <a:bodyPr/>
+                    <a:lstStyle/>
+                    <a:p>
+                      <a:pPr>
+                        <a:defRPr sz="900"/>
+                      </a:pPr>
+                      <a:r>
+                        <a:t>—</a:t>
+                      </a:r>
+                    </a:p>
+                  </a:txBody>
+                  <a:tcPr/>
+                </a:tc>
+              </a:tr>
+              <a:tr h="337185">
+                <a:tc>
+                  <a:txBody>
+                    <a:bodyPr/>
+                    <a:lstStyle/>
+                    <a:p>
+                      <a:pPr>
+                        <a:defRPr sz="900" b="1"/>
+                      </a:pPr>
+                      <a:r>
+                        <a:t>(+39.0, 28)</a:t>
+                      </a:r>
+                    </a:p>
+                  </a:txBody>
+                  <a:tcPr/>
+                </a:tc>
+                <a:tc>
+                  <a:txBody>
+                    <a:bodyPr/>
+                    <a:lstStyle/>
+                    <a:p>
+                      <a:pPr>
+                        <a:defRPr sz="900"/>
+                      </a:pPr>
+                      <a:r>
+                        <a:t>(−38, 37)*</a:t>
+                      </a:r>
+                    </a:p>
+                  </a:txBody>
+                  <a:tcPr/>
+                </a:tc>
+                <a:tc>
+                  <a:txBody>
+                    <a:bodyPr/>
+                    <a:lstStyle/>
+                    <a:p>
+                      <a:pPr>
+                        <a:defRPr sz="900"/>
+                      </a:pPr>
+                      <a:r>
+                        <a:t>+42</a:t>
+                      </a:r>
+                    </a:p>
+                  </a:txBody>
+                  <a:tcPr/>
+                </a:tc>
+                <a:tc>
+                  <a:txBody>
+                    <a:bodyPr/>
+                    <a:lstStyle/>
+                    <a:p>
+                      <a:pPr>
+                        <a:defRPr sz="900"/>
+                      </a:pPr>
+                      <a:r>
+                        <a:t>+42</a:t>
+                      </a:r>
+                    </a:p>
+                  </a:txBody>
+                  <a:tcPr/>
+                </a:tc>
+                <a:tc>
+                  <a:txBody>
+                    <a:bodyPr/>
+                    <a:lstStyle/>
+                    <a:p>
+                      <a:pPr>
+                        <a:defRPr sz="900"/>
+                      </a:pPr>
+                      <a:r>
+                        <a:t>+38/40</a:t>
+                      </a:r>
+                    </a:p>
+                  </a:txBody>
+                  <a:tcPr/>
+                </a:tc>
+                <a:tc>
+                  <a:txBody>
+                    <a:bodyPr/>
+                    <a:lstStyle/>
+                    <a:p>
+                      <a:pPr>
+                        <a:defRPr sz="900"/>
+                      </a:pPr>
+                      <a:r>
+                        <a:t>(+37.6, 27)</a:t>
+                      </a:r>
+                    </a:p>
+                  </a:txBody>
+                  <a:tcPr/>
+                </a:tc>
+                <a:tc>
+                  <a:txBody>
+                    <a:bodyPr/>
+                    <a:lstStyle/>
+                    <a:p>
+                      <a:pPr>
+                        <a:defRPr sz="900"/>
+                      </a:pPr>
+                      <a:r>
+                        <a:t>(+40.7, 33)</a:t>
+                      </a:r>
+                    </a:p>
+                  </a:txBody>
+                  <a:tcPr/>
+                </a:tc>
+                <a:tc>
+                  <a:txBody>
+                    <a:bodyPr/>
+                    <a:lstStyle/>
+                    <a:p>
+                      <a:pPr>
+                        <a:defRPr sz="900"/>
+                      </a:pPr>
+                      <a:r>
+                        <a:t>(+37.5, 28)</a:t>
+                      </a:r>
+                    </a:p>
+                  </a:txBody>
+                  <a:tcPr/>
+                </a:tc>
+              </a:tr>
+              <a:tr h="337185">
+                <a:tc>
+                  <a:txBody>
+                    <a:bodyPr/>
+                    <a:lstStyle/>
+                    <a:p>
+                      <a:pPr>
+                        <a:defRPr sz="900" b="1"/>
+                      </a:pPr>
+                      <a:r>
+                        <a:t>(+48.0, 25)</a:t>
+                      </a:r>
+                    </a:p>
+                  </a:txBody>
+                  <a:tcPr/>
+                </a:tc>
+                <a:tc>
+                  <a:txBody>
+                    <a:bodyPr/>
+                    <a:lstStyle/>
+                    <a:p>
+                      <a:pPr>
+                        <a:defRPr sz="900"/>
+                      </a:pPr>
+                      <a:r>
+                        <a:t>—</a:t>
+                      </a:r>
+                    </a:p>
+                  </a:txBody>
+                  <a:tcPr/>
+                </a:tc>
+                <a:tc>
+                  <a:txBody>
+                    <a:bodyPr/>
+                    <a:lstStyle/>
+                    <a:p>
+                      <a:pPr>
+                        <a:defRPr sz="900"/>
+                      </a:pPr>
+                      <a:r>
+                        <a:t>+46</a:t>
+                      </a:r>
+                    </a:p>
+                  </a:txBody>
+                  <a:tcPr/>
+                </a:tc>
+                <a:tc>
+                  <a:txBody>
+                    <a:bodyPr/>
+                    <a:lstStyle/>
+                    <a:p>
+                      <a:pPr>
+                        <a:defRPr sz="900"/>
+                      </a:pPr>
+                      <a:r>
+                        <a:t>—</a:t>
+                      </a:r>
+                    </a:p>
+                  </a:txBody>
+                  <a:tcPr/>
+                </a:tc>
+                <a:tc>
+                  <a:txBody>
+                    <a:bodyPr/>
+                    <a:lstStyle/>
+                    <a:p>
+                      <a:pPr>
+                        <a:defRPr sz="900"/>
+                      </a:pPr>
+                      <a:r>
+                        <a:t>—</a:t>
+                      </a:r>
+                    </a:p>
+                  </a:txBody>
+                  <a:tcPr/>
+                </a:tc>
+                <a:tc>
+                  <a:txBody>
+                    <a:bodyPr/>
+                    <a:lstStyle/>
+                    <a:p>
+                      <a:pPr>
+                        <a:defRPr sz="900"/>
+                      </a:pPr>
+                      <a:r>
+                        <a:t>—</a:t>
+                      </a:r>
+                    </a:p>
+                  </a:txBody>
+                  <a:tcPr/>
+                </a:tc>
+                <a:tc>
+                  <a:txBody>
+                    <a:bodyPr/>
+                    <a:lstStyle/>
+                    <a:p>
+                      <a:pPr>
+                        <a:defRPr sz="900"/>
+                      </a:pPr>
+                      <a:r>
+                        <a:t>—</a:t>
+                      </a:r>
+                    </a:p>
+                  </a:txBody>
+                  <a:tcPr/>
+                </a:tc>
+                <a:tc>
+                  <a:txBody>
+                    <a:bodyPr/>
+                    <a:lstStyle/>
+                    <a:p>
+                      <a:pPr>
+                        <a:defRPr sz="900"/>
+                      </a:pPr>
+                      <a:r>
+                        <a:t>(+45.0, 33)</a:t>
+                      </a:r>
+                    </a:p>
+                  </a:txBody>
+                  <a:tcPr/>
+                </a:tc>
+              </a:tr>
+              <a:tr h="337185">
+                <a:tc>
+                  <a:txBody>
+                    <a:bodyPr/>
+                    <a:lstStyle/>
+                    <a:p>
+                      <a:pPr>
+                        <a:defRPr sz="900" b="1"/>
+                      </a:pPr>
+                      <a:r>
+                        <a:t>(+65.6, 28)</a:t>
+                      </a:r>
+                    </a:p>
+                  </a:txBody>
+                  <a:tcPr/>
+                </a:tc>
+                <a:tc>
+                  <a:txBody>
+                    <a:bodyPr/>
+                    <a:lstStyle/>
+                    <a:p>
+                      <a:pPr>
+                        <a:defRPr sz="900"/>
+                      </a:pPr>
+                      <a:r>
+                        <a:t>—</a:t>
+                      </a:r>
+                    </a:p>
+                  </a:txBody>
+                  <a:tcPr/>
+                </a:tc>
+                <a:tc>
+                  <a:txBody>
+                    <a:bodyPr/>
+                    <a:lstStyle/>
+                    <a:p>
+                      <a:pPr>
+                        <a:defRPr sz="900"/>
+                      </a:pPr>
+                      <a:r>
+                        <a:t>—</a:t>
+                      </a:r>
+                    </a:p>
+                  </a:txBody>
+                  <a:tcPr/>
+                </a:tc>
+                <a:tc>
+                  <a:txBody>
+                    <a:bodyPr/>
+                    <a:lstStyle/>
+                    <a:p>
+                      <a:pPr>
+                        <a:defRPr sz="900"/>
+                      </a:pPr>
+                      <a:r>
+                        <a:t>—</a:t>
+                      </a:r>
+                    </a:p>
+                  </a:txBody>
+                  <a:tcPr/>
+                </a:tc>
+                <a:tc>
+                  <a:txBody>
+                    <a:bodyPr/>
+                    <a:lstStyle/>
+                    <a:p>
+                      <a:pPr>
+                        <a:defRPr sz="900"/>
+                      </a:pPr>
+                      <a:r>
+                        <a:t>+64</a:t>
+                      </a:r>
+                    </a:p>
+                  </a:txBody>
+                  <a:tcPr/>
+                </a:tc>
+                <a:tc>
+                  <a:txBody>
+                    <a:bodyPr/>
+                    <a:lstStyle/>
+                    <a:p>
+                      <a:pPr>
+                        <a:defRPr sz="900"/>
+                      </a:pPr>
+                      <a:r>
+                        <a:t>—</a:t>
+                      </a:r>
+                    </a:p>
+                  </a:txBody>
+                  <a:tcPr/>
+                </a:tc>
+                <a:tc>
+                  <a:txBody>
+                    <a:bodyPr/>
+                    <a:lstStyle/>
+                    <a:p>
+                      <a:pPr>
+                        <a:defRPr sz="900"/>
+                      </a:pPr>
+                      <a:r>
+                        <a:t>(+65.2, 30)</a:t>
+                      </a:r>
+                    </a:p>
+                  </a:txBody>
+                  <a:tcPr/>
+                </a:tc>
+                <a:tc>
+                  <a:txBody>
+                    <a:bodyPr/>
+                    <a:lstStyle/>
+                    <a:p>
+                      <a:pPr>
+                        <a:defRPr sz="900"/>
+                      </a:pPr>
+                      <a:r>
+                        <a:t>—</a:t>
+                      </a:r>
+                    </a:p>
+                  </a:txBody>
+                  <a:tcPr/>
+                </a:tc>
+              </a:tr>
+              <a:tr h="337185">
+                <a:tc>
+                  <a:txBody>
+                    <a:bodyPr/>
+                    <a:lstStyle/>
+                    <a:p>
+                      <a:pPr>
+                        <a:defRPr sz="900" b="1"/>
+                      </a:pPr>
+                      <a:r>
+                        <a:t>(+91.9, 33)</a:t>
+                      </a:r>
+                    </a:p>
+                  </a:txBody>
+                  <a:tcPr/>
+                </a:tc>
+                <a:tc>
+                  <a:txBody>
+                    <a:bodyPr/>
+                    <a:lstStyle/>
+                    <a:p>
+                      <a:pPr>
+                        <a:defRPr sz="900"/>
+                      </a:pPr>
+                      <a:r>
+                        <a:t>—</a:t>
+                      </a:r>
+                    </a:p>
+                  </a:txBody>
+                  <a:tcPr/>
+                </a:tc>
+                <a:tc>
+                  <a:txBody>
+                    <a:bodyPr/>
+                    <a:lstStyle/>
+                    <a:p>
+                      <a:pPr>
+                        <a:defRPr sz="900"/>
+                      </a:pPr>
+                      <a:r>
+                        <a:t>—</a:t>
+                      </a:r>
+                    </a:p>
+                  </a:txBody>
+                  <a:tcPr/>
+                </a:tc>
+                <a:tc>
+                  <a:txBody>
+                    <a:bodyPr/>
+                    <a:lstStyle/>
+                    <a:p>
+                      <a:pPr>
+                        <a:defRPr sz="900"/>
+                      </a:pPr>
+                      <a:r>
+                        <a:t>—</a:t>
+                      </a:r>
+                    </a:p>
+                  </a:txBody>
+                  <a:tcPr/>
+                </a:tc>
+                <a:tc>
+                  <a:txBody>
+                    <a:bodyPr/>
+                    <a:lstStyle/>
+                    <a:p>
+                      <a:pPr>
+                        <a:defRPr sz="900"/>
+                      </a:pPr>
+                      <a:r>
+                        <a:t>+92</a:t>
+                      </a:r>
+                    </a:p>
+                  </a:txBody>
+                  <a:tcPr/>
+                </a:tc>
+                <a:tc>
+                  <a:txBody>
+                    <a:bodyPr/>
+                    <a:lstStyle/>
+                    <a:p>
+                      <a:pPr>
+                        <a:defRPr sz="900"/>
+                      </a:pPr>
+                      <a:r>
+                        <a:t>—</a:t>
+                      </a:r>
+                    </a:p>
+                  </a:txBody>
+                  <a:tcPr/>
+                </a:tc>
+                <a:tc>
+                  <a:txBody>
+                    <a:bodyPr/>
+                    <a:lstStyle/>
+                    <a:p>
+                      <a:pPr>
+                        <a:defRPr sz="900"/>
+                      </a:pPr>
+                      <a:r>
+                        <a:t>(+91.2, 36)</a:t>
+                      </a:r>
+                    </a:p>
+                  </a:txBody>
+                  <a:tcPr/>
+                </a:tc>
+                <a:tc>
+                  <a:txBody>
+                    <a:bodyPr/>
+                    <a:lstStyle/>
+                    <a:p>
+                      <a:pPr>
+                        <a:defRPr sz="900"/>
+                      </a:pPr>
+                      <a:r>
+                        <a:t>—</a:t>
+                      </a:r>
+                    </a:p>
+                  </a:txBody>
+                  <a:tcPr/>
+                </a:tc>
+              </a:tr>
+              <a:tr h="337185">
+                <a:tc>
+                  <a:txBody>
+                    <a:bodyPr/>
+                    <a:lstStyle/>
+                    <a:p>
+                      <a:pPr>
+                        <a:defRPr sz="900" b="1"/>
+                      </a:pPr>
+                      <a:r>
+                        <a:t>(+114.4, 24)</a:t>
+                      </a:r>
+                    </a:p>
+                  </a:txBody>
+                  <a:tcPr/>
+                </a:tc>
+                <a:tc>
+                  <a:txBody>
+                    <a:bodyPr/>
+                    <a:lstStyle/>
+                    <a:p>
+                      <a:pPr>
+                        <a:defRPr sz="900"/>
+                      </a:pPr>
+                      <a:r>
+                        <a:t>—</a:t>
+                      </a:r>
+                    </a:p>
+                  </a:txBody>
+                  <a:tcPr/>
+                </a:tc>
+                <a:tc>
+                  <a:txBody>
+                    <a:bodyPr/>
+                    <a:lstStyle/>
+                    <a:p>
+                      <a:pPr>
+                        <a:defRPr sz="900"/>
+                      </a:pPr>
+                      <a:r>
+                        <a:t>—</a:t>
+                      </a:r>
+                    </a:p>
+                  </a:txBody>
+                  <a:tcPr/>
+                </a:tc>
+                <a:tc>
+                  <a:txBody>
+                    <a:bodyPr/>
+                    <a:lstStyle/>
+                    <a:p>
+                      <a:pPr>
+                        <a:defRPr sz="900"/>
+                      </a:pPr>
+                      <a:r>
+                        <a:t>—</a:t>
+                      </a:r>
+                    </a:p>
+                  </a:txBody>
+                  <a:tcPr/>
+                </a:tc>
+                <a:tc>
+                  <a:txBody>
+                    <a:bodyPr/>
+                    <a:lstStyle/>
+                    <a:p>
+                      <a:pPr>
+                        <a:defRPr sz="900"/>
+                      </a:pPr>
+                      <a:r>
+                        <a:t>+116</a:t>
+                      </a:r>
+                    </a:p>
+                  </a:txBody>
+                  <a:tcPr/>
+                </a:tc>
+                <a:tc>
+                  <a:txBody>
+                    <a:bodyPr/>
+                    <a:lstStyle/>
+                    <a:p>
+                      <a:pPr>
+                        <a:defRPr sz="900"/>
+                      </a:pPr>
+                      <a:r>
+                        <a:t>—</a:t>
+                      </a:r>
+                    </a:p>
+                  </a:txBody>
+                  <a:tcPr/>
+                </a:tc>
+                <a:tc>
+                  <a:txBody>
+                    <a:bodyPr/>
+                    <a:lstStyle/>
+                    <a:p>
+                      <a:pPr>
+                        <a:defRPr sz="900"/>
+                      </a:pPr>
+                      <a:r>
+                        <a:t>—</a:t>
+                      </a:r>
+                    </a:p>
+                  </a:txBody>
+                  <a:tcPr/>
+                </a:tc>
+                <a:tc>
+                  <a:txBody>
+                    <a:bodyPr/>
+                    <a:lstStyle/>
+                    <a:p>
+                      <a:pPr>
+                        <a:defRPr sz="900"/>
+                      </a:pPr>
+                      <a:r>
+                        <a:t>—</a:t>
+                      </a:r>
+                    </a:p>
+                  </a:txBody>
+                  <a:tcPr/>
+                </a:tc>
+              </a:tr>
+              <a:tr h="337185">
+                <a:tc>
+                  <a:txBody>
+                    <a:bodyPr/>
+                    <a:lstStyle/>
+                    <a:p>
+                      <a:pPr>
+                        <a:defRPr sz="900" b="1"/>
+                      </a:pPr>
+                      <a:r>
+                        <a:t>후보 (−34?)</a:t>
+                      </a:r>
+                    </a:p>
+                  </a:txBody>
+                  <a:tcPr/>
+                </a:tc>
+                <a:tc>
+                  <a:txBody>
+                    <a:bodyPr/>
+                    <a:lstStyle/>
+                    <a:p>
+                      <a:pPr>
+                        <a:defRPr sz="900"/>
+                      </a:pPr>
+                      <a:r>
+                        <a:t>(−38, 37)?</a:t>
+                      </a:r>
+                    </a:p>
+                  </a:txBody>
+                  <a:tcPr/>
+                </a:tc>
+                <a:tc>
+                  <a:txBody>
+                    <a:bodyPr/>
+                    <a:lstStyle/>
+                    <a:p>
+                      <a:pPr>
+                        <a:defRPr sz="900"/>
+                      </a:pPr>
+                      <a:r>
+                        <a:t>−34</a:t>
+                      </a:r>
+                    </a:p>
+                  </a:txBody>
+                  <a:tcPr/>
+                </a:tc>
+                <a:tc>
+                  <a:txBody>
+                    <a:bodyPr/>
+                    <a:lstStyle/>
+                    <a:p>
+                      <a:pPr>
+                        <a:defRPr sz="900"/>
+                      </a:pPr>
+                      <a:r>
+                        <a:t>−30</a:t>
+                      </a:r>
+                    </a:p>
+                  </a:txBody>
+                  <a:tcPr/>
+                </a:tc>
+                <a:tc>
+                  <a:txBody>
+                    <a:bodyPr/>
+                    <a:lstStyle/>
+                    <a:p>
+                      <a:pPr>
+                        <a:defRPr sz="900"/>
+                      </a:pPr>
+                      <a:r>
+                        <a:t>—</a:t>
+                      </a:r>
+                    </a:p>
+                  </a:txBody>
+                  <a:tcPr/>
+                </a:tc>
+                <a:tc>
+                  <a:txBody>
+                    <a:bodyPr/>
+                    <a:lstStyle/>
+                    <a:p>
+                      <a:pPr>
+                        <a:defRPr sz="900"/>
+                      </a:pPr>
+                      <a:r>
+                        <a:t>(−34.4, 17)</a:t>
+                      </a:r>
+                    </a:p>
+                  </a:txBody>
+                  <a:tcPr/>
+                </a:tc>
+                <a:tc>
+                  <a:txBody>
+                    <a:bodyPr/>
+                    <a:lstStyle/>
+                    <a:p>
+                      <a:pPr>
+                        <a:defRPr sz="900"/>
+                      </a:pPr>
+                      <a:r>
+                        <a:t>—</a:t>
+                      </a:r>
+                    </a:p>
+                  </a:txBody>
+                  <a:tcPr/>
+                </a:tc>
+                <a:tc>
+                  <a:txBody>
+                    <a:bodyPr/>
+                    <a:lstStyle/>
+                    <a:p>
+                      <a:pPr>
+                        <a:defRPr sz="900"/>
+                      </a:pPr>
+                      <a:r>
+                        <a:t>—</a:t>
+                      </a:r>
+                    </a:p>
+                  </a:txBody>
+                  <a:tcPr/>
+                </a:tc>
+              </a:tr>
+            </a:tbl>
+          </a:graphicData>
+        </a:graphic>
+      </p:graphicFrame>
+    </p:spTree>
+  </p:cSld>
+  <p:clrMapOvr>
+    <a:masterClrMapping/>
+  </p:clrMapOvr>
+</p:sld>
+</file>
+
+<file path=ppt/slides/slide11.xml><?xml version="1.0" encoding="utf-8"?>
+<p:sld xmlns:a="http://schemas.openxmlformats.org/drawingml/2006/main" xmlns:p="http://schemas.openxmlformats.org/presentationml/2006/main" xmlns:r="http://schemas.openxmlformats.org/officeDocument/2006/relationships">
+  <p:cSld>
+    <p:spTree>
+      <p:nvGrpSpPr>
+        <p:cNvPr id="1" name=""/>
+        <p:cNvGrpSpPr/>
+        <p:nvPr/>
+      </p:nvGrpSpPr>
+      <p:grpSpPr/>
+      <p:sp>
+        <p:nvSpPr>
+          <p:cNvPr id="2" name="TextBox 1"/>
+          <p:cNvSpPr txBox="1"/>
+          <p:nvPr/>
+        </p:nvSpPr>
+        <p:spPr>
+          <a:xfrm>
+            <a:off x="365760" y="109728"/>
+            <a:ext cx="11430000" cy="914400"/>
+          </a:xfrm>
+          <a:prstGeom prst="rect">
+            <a:avLst/>
+          </a:prstGeom>
+          <a:noFill/>
+        </p:spPr>
+        <p:txBody>
+          <a:bodyPr wrap="none">
+            <a:spAutoFit/>
+          </a:bodyPr>
+          <a:lstStyle/>
+          <a:p>
+            <a:pPr>
+              <a:defRPr sz="2600" b="1"/>
+            </a:pPr>
+            <a:r>
               <a:t>NV2: 알고리즘별 A-텐서 값 종합표</a:t>
             </a:r>
           </a:p>
           <a:p>
             <a:pPr>
-              <a:defRPr sz="1300"/>
+              <a:defRPr sz="1200"/>
             </a:pPr>
             <a:r>
               <a:t>값 = (A∥, A⊥) kHz · CPMG-16 단일 채널 · ⚠ = 축퇴 잔재 보류 · 앵커 3/3 회수</a:t>
+            </a:r>
+          </a:p>
+          <a:p>
+            <a:pPr>
+              <a:defRPr sz="1400" b="1">
+                <a:solidFill>
+                  <a:srgbClr val="B45000"/>
+                </a:solidFill>
+              </a:defRPr>
+            </a:pPr>
+            <a:r>
+              <a:t>▶ 수동 분석 3개를 전부 회수하고 신규 7개를 추가 — 사람 눈의 상위집합</a:t>
             </a:r>
           </a:p>
         </p:txBody>
@@ -4348,8 +6458,8 @@
         </p:nvSpPr>
         <p:spPr>
           <a:xfrm>
-            <a:off x="365760" y="137160"/>
-            <a:ext cx="11430000" cy="822960"/>
+            <a:off x="365760" y="109728"/>
+            <a:ext cx="11430000" cy="914400"/>
           </a:xfrm>
           <a:prstGeom prst="rect">
             <a:avLst/>
@@ -4363,7 +6473,7 @@
           <a:lstStyle/>
           <a:p>
             <a:pPr>
-              <a:defRPr sz="2800" b="1"/>
+              <a:defRPr sz="2600" b="1"/>
             </a:pPr>
             <a:r>
               <a:t>제안 모델: PF→DE 하이브리드</a:t>
@@ -4371,10 +6481,22 @@
           </a:p>
           <a:p>
             <a:pPr>
-              <a:defRPr sz="1300"/>
+              <a:defRPr sz="1200"/>
             </a:pPr>
             <a:r>
               <a:t>상온 NV CPMG에서 ¹³C 핵스핀 (A∥, A⊥) 자동 추출</a:t>
+            </a:r>
+          </a:p>
+          <a:p>
+            <a:pPr>
+              <a:defRPr sz="1400" b="1">
+                <a:solidFill>
+                  <a:srgbClr val="B45000"/>
+                </a:solidFill>
+              </a:defRPr>
+            </a:pPr>
+            <a:r>
+              <a:t>▶ 어디에 있나(신경망 검출)와 몇 개·얼마나 강한가(물리 피팅)를 분리하니 둘 다 잘하게 됐다</a:t>
             </a:r>
           </a:p>
         </p:txBody>
@@ -4476,8 +6598,8 @@
         </p:nvSpPr>
         <p:spPr>
           <a:xfrm>
-            <a:off x="365760" y="137160"/>
-            <a:ext cx="11430000" cy="822960"/>
+            <a:off x="365760" y="109728"/>
+            <a:ext cx="11430000" cy="914400"/>
           </a:xfrm>
           <a:prstGeom prst="rect">
             <a:avLst/>
@@ -4491,7 +6613,7 @@
           <a:lstStyle/>
           <a:p>
             <a:pPr>
-              <a:defRPr sz="2800" b="1"/>
+              <a:defRPr sz="2600" b="1"/>
             </a:pPr>
             <a:r>
               <a:t>모델 내부: 데이터가 어떻게 흘러 무엇이 되는가</a:t>
@@ -4499,10 +6621,22 @@
           </a:p>
           <a:p>
             <a:pPr>
-              <a:defRPr sz="1300"/>
+              <a:defRPr sz="1200"/>
             </a:pPr>
             <a:r>
               <a:t>블록 위 = 연산, 붉은 글씨 = 텐서 shape · 입력(파랑) → 연산(초록) → 출력(보라)</a:t>
+            </a:r>
+          </a:p>
+          <a:p>
+            <a:pPr>
+              <a:defRPr sz="1400" b="1">
+                <a:solidFill>
+                  <a:srgbClr val="B45000"/>
+                </a:solidFill>
+              </a:defRPr>
+            </a:pPr>
+            <a:r>
+              <a:t>▶ 모델 간 본질적 차이는 정보가 어디서 합쳐지는가 — 2021은 끝까지 안 합치고, 우리는 어텐션에서 합친다</a:t>
             </a:r>
           </a:p>
         </p:txBody>
@@ -4596,8 +6730,8 @@
         </p:nvSpPr>
         <p:spPr>
           <a:xfrm>
-            <a:off x="365760" y="137160"/>
-            <a:ext cx="11430000" cy="822960"/>
+            <a:off x="365760" y="109728"/>
+            <a:ext cx="11430000" cy="914400"/>
           </a:xfrm>
           <a:prstGeom prst="rect">
             <a:avLst/>
@@ -4611,7 +6745,7 @@
           <a:lstStyle/>
           <a:p>
             <a:pPr>
-              <a:defRPr sz="2800" b="1"/>
+              <a:defRPr sz="2600" b="1"/>
             </a:pPr>
             <a:r>
               <a:t>아키텍처 비교: 2021 → 하이브리드</a:t>
@@ -4619,10 +6753,22 @@
           </a:p>
           <a:p>
             <a:pPr>
-              <a:defRPr sz="1300"/>
+              <a:defRPr sz="1200"/>
             </a:pPr>
             <a:r>
               <a:t>같은 조건·같은 합성 GT에서 재학습해 공정 비교 (ablation)</a:t>
+            </a:r>
+          </a:p>
+          <a:p>
+            <a:pPr>
+              <a:defRPr sz="1400" b="1">
+                <a:solidFill>
+                  <a:srgbClr val="B45000"/>
+                </a:solidFill>
+              </a:defRPr>
+            </a:pPr>
+            <a:r>
+              <a:t>▶ 상온 조건에서 2021 F1 0.57 → 제안 0.94 — 향상분이 어느 설계에서 왔는지 숫자로 분리했다</a:t>
             </a:r>
           </a:p>
         </p:txBody>
@@ -4732,8 +6878,8 @@
         </p:nvSpPr>
         <p:spPr>
           <a:xfrm>
-            <a:off x="365760" y="137160"/>
-            <a:ext cx="11430000" cy="822960"/>
+            <a:off x="365760" y="109728"/>
+            <a:ext cx="11430000" cy="914400"/>
           </a:xfrm>
           <a:prstGeom prst="rect">
             <a:avLst/>
@@ -4747,18 +6893,162 @@
           <a:lstStyle/>
           <a:p>
             <a:pPr>
-              <a:defRPr sz="2800" b="1"/>
+              <a:defRPr sz="2600" b="1"/>
             </a:pPr>
             <a:r>
+              <a:t>비유로 이해하는 다섯 설계</a:t>
+            </a:r>
+          </a:p>
+          <a:p>
+            <a:pPr>
+              <a:defRPr sz="1200"/>
+            </a:pPr>
+            <a:r>
+              <a:t>딥러닝을 몰라도 되는 설명 — 각 방법이 무엇을 하고, 왜 그렇게 바꿨는가</a:t>
+            </a:r>
+          </a:p>
+          <a:p>
+            <a:pPr>
+              <a:defRPr sz="1400" b="1">
+                <a:solidFill>
+                  <a:srgbClr val="B45000"/>
+                </a:solidFill>
+              </a:defRPr>
+            </a:pPr>
+            <a:r>
+              <a:t>▶ 설계 변경은 취향이 아니라 진단이다 — 앞 방법이 실패하는 지점을 하나씩 고쳤다</a:t>
+            </a:r>
+          </a:p>
+        </p:txBody>
+      </p:sp>
+      <p:pic>
+        <p:nvPicPr>
+          <p:cNvPr id="3" name="Picture 2" descr="analogy.png"/>
+          <p:cNvPicPr>
+            <a:picLocks noChangeAspect="1"/>
+          </p:cNvPicPr>
+          <p:nvPr/>
+        </p:nvPicPr>
+        <p:blipFill>
+          <a:blip r:embed="rId2"/>
+          <a:stretch>
+            <a:fillRect/>
+          </a:stretch>
+        </p:blipFill>
+        <p:spPr>
+          <a:xfrm>
+            <a:off x="320040" y="1325880"/>
+            <a:ext cx="11521440" cy="4590077"/>
+          </a:xfrm>
+          <a:prstGeom prst="rect">
+            <a:avLst/>
+          </a:prstGeom>
+        </p:spPr>
+      </p:pic>
+      <p:sp>
+        <p:nvSpPr>
+          <p:cNvPr id="4" name="TextBox 3"/>
+          <p:cNvSpPr txBox="1"/>
+          <p:nvPr/>
+        </p:nvSpPr>
+        <p:spPr>
+          <a:xfrm>
+            <a:off x="457200" y="5943600"/>
+            <a:ext cx="11247120" cy="2286000"/>
+          </a:xfrm>
+          <a:prstGeom prst="rect">
+            <a:avLst/>
+          </a:prstGeom>
+          <a:noFill/>
+        </p:spPr>
+        <p:txBody>
+          <a:bodyPr wrap="square">
+            <a:spAutoFit/>
+          </a:bodyPr>
+          <a:lstStyle/>
+          <a:p>
+            <a:pPr>
+              <a:defRPr sz="1250"/>
+            </a:pPr>
+            <a:r>
+              <a:t>• 왜 회의(어텐션)가 결정적인가: 상온 노이즈는 한 창문에서는 스핀처럼 보일 수 있지만, 이웃 창문들과 대조하면 들통난다 — 그래서 PeriodFormer의 오탐이 0이 된다</a:t>
+            </a:r>
+          </a:p>
+          <a:p>
+            <a:pPr>
+              <a:defRPr sz="1250"/>
+            </a:pPr>
+            <a:r>
+              <a:t>• 왜 측량사(물리 피팅)가 필요한가: 회의는 이 근처에 있다까지만 안다 — 한 구역에 몇 개가 겹쳐 있는지는 물리 공식을 데이터에 맞춰봐야(BIC) 알 수 있다</a:t>
+            </a:r>
+          </a:p>
+        </p:txBody>
+      </p:sp>
+    </p:spTree>
+  </p:cSld>
+  <p:clrMapOvr>
+    <a:masterClrMapping/>
+  </p:clrMapOvr>
+</p:sld>
+</file>
+
+<file path=ppt/slides/slide6.xml><?xml version="1.0" encoding="utf-8"?>
+<p:sld xmlns:a="http://schemas.openxmlformats.org/drawingml/2006/main" xmlns:p="http://schemas.openxmlformats.org/presentationml/2006/main" xmlns:r="http://schemas.openxmlformats.org/officeDocument/2006/relationships">
+  <p:cSld>
+    <p:spTree>
+      <p:nvGrpSpPr>
+        <p:cNvPr id="1" name=""/>
+        <p:cNvGrpSpPr/>
+        <p:nvPr/>
+      </p:nvGrpSpPr>
+      <p:grpSpPr/>
+      <p:sp>
+        <p:nvSpPr>
+          <p:cNvPr id="2" name="TextBox 1"/>
+          <p:cNvSpPr txBox="1"/>
+          <p:nvPr/>
+        </p:nvSpPr>
+        <p:spPr>
+          <a:xfrm>
+            <a:off x="365760" y="109728"/>
+            <a:ext cx="11430000" cy="914400"/>
+          </a:xfrm>
+          <a:prstGeom prst="rect">
+            <a:avLst/>
+          </a:prstGeom>
+          <a:noFill/>
+        </p:spPr>
+        <p:txBody>
+          <a:bodyPr wrap="none">
+            <a:spAutoFit/>
+          </a:bodyPr>
+          <a:lstStyle/>
+          <a:p>
+            <a:pPr>
+              <a:defRPr sz="2600" b="1"/>
+            </a:pPr>
+            <a:r>
               <a:t>검증: 3중 근거</a:t>
             </a:r>
           </a:p>
           <a:p>
             <a:pPr>
-              <a:defRPr sz="1300"/>
+              <a:defRPr sz="1200"/>
             </a:pPr>
             <a:r>
               <a:t>① 합성 GT ② 실측 50-스핀 디지털 트윈(공개 데이터·테스트 전용) ③ 실데이터 교차 수렴</a:t>
+            </a:r>
+          </a:p>
+          <a:p>
+            <a:pPr>
+              <a:defRPr sz="1400" b="1">
+                <a:solidFill>
+                  <a:srgbClr val="B45000"/>
+                </a:solidFill>
+              </a:defRPr>
+            </a:pPr>
+            <a:r>
+              <a:t>▶ 정답을 아는 실제 스핀 환경(Delft 공개 데이터)에서 저온·상온·오차주입 전 조건 1위</a:t>
             </a:r>
           </a:p>
         </p:txBody>
@@ -4866,7 +7156,7 @@
 </p:sld>
 </file>
 
-<file path=ppt/slides/slide6.xml><?xml version="1.0" encoding="utf-8"?>
+<file path=ppt/slides/slide7.xml><?xml version="1.0" encoding="utf-8"?>
 <p:sld xmlns:a="http://schemas.openxmlformats.org/drawingml/2006/main" xmlns:p="http://schemas.openxmlformats.org/presentationml/2006/main" xmlns:r="http://schemas.openxmlformats.org/officeDocument/2006/relationships">
   <p:cSld>
     <p:spTree>
@@ -4884,8 +7174,8 @@
         </p:nvSpPr>
         <p:spPr>
           <a:xfrm>
-            <a:off x="365760" y="137160"/>
-            <a:ext cx="11430000" cy="822960"/>
+            <a:off x="365760" y="109728"/>
+            <a:ext cx="11430000" cy="914400"/>
           </a:xfrm>
           <a:prstGeom prst="rect">
             <a:avLst/>
@@ -4899,7 +7189,7 @@
           <a:lstStyle/>
           <a:p>
             <a:pPr>
-              <a:defRPr sz="2800" b="1"/>
+              <a:defRPr sz="2600" b="1"/>
             </a:pPr>
             <a:r>
               <a:t>피팅 곡선은 이렇게 그린다</a:t>
@@ -4907,10 +7197,22 @@
           </a:p>
           <a:p>
             <a:pPr>
-              <a:defRPr sz="1300"/>
+              <a:defRPr sz="1200"/>
             </a:pPr>
             <a:r>
               <a:t>스핀 목록 → 곱 공식 → 곡선 1개 (스핀 수 6~10은 각 방법의 BIC 자동 선택 결과)</a:t>
+            </a:r>
+          </a:p>
+          <a:p>
+            <a:pPr>
+              <a:defRPr sz="1400" b="1">
+                <a:solidFill>
+                  <a:srgbClr val="B45000"/>
+                </a:solidFill>
+              </a:defRPr>
+            </a:pPr>
+            <a:r>
+              <a:t>▶ 곡선은 그린 것이 아니라 스핀 목록에서 물리 공식으로 계산된 예측 — 데이터와 맞으면 목록이 맞다는 뜻</a:t>
             </a:r>
           </a:p>
         </p:txBody>
@@ -4994,7 +7296,7 @@
 </p:sld>
 </file>
 
-<file path=ppt/slides/slide7.xml><?xml version="1.0" encoding="utf-8"?>
+<file path=ppt/slides/slide8.xml><?xml version="1.0" encoding="utf-8"?>
 <p:sld xmlns:a="http://schemas.openxmlformats.org/drawingml/2006/main" xmlns:p="http://schemas.openxmlformats.org/presentationml/2006/main" xmlns:r="http://schemas.openxmlformats.org/officeDocument/2006/relationships">
   <p:cSld>
     <p:spTree>
@@ -5012,8 +7314,8 @@
         </p:nvSpPr>
         <p:spPr>
           <a:xfrm>
-            <a:off x="365760" y="137160"/>
-            <a:ext cx="11430000" cy="822960"/>
+            <a:off x="365760" y="109728"/>
+            <a:ext cx="11430000" cy="914400"/>
           </a:xfrm>
           <a:prstGeom prst="rect">
             <a:avLst/>
@@ -5027,7 +7329,7 @@
           <a:lstStyle/>
           <a:p>
             <a:pPr>
-              <a:defRPr sz="2800" b="1"/>
+              <a:defRPr sz="2600" b="1"/>
             </a:pPr>
             <a:r>
               <a:t>NV1: 모델별 피팅 오버레이 + 검출 결합강도</a:t>
@@ -5035,10 +7337,22 @@
           </a:p>
           <a:p>
             <a:pPr>
-              <a:defRPr sz="1300"/>
+              <a:defRPr sz="1200"/>
             </a:pPr>
             <a:r>
               <a:t>회색 = 실험 데이터(행마다 반복) · 곡선 색 = 알고리즘 · (A∥, A⊥) kHz</a:t>
+            </a:r>
+          </a:p>
+          <a:p>
+            <a:pPr>
+              <a:defRPr sz="1400" b="1">
+                <a:solidFill>
+                  <a:srgbClr val="B45000"/>
+                </a:solidFill>
+              </a:defRPr>
+            </a:pPr>
+            <a:r>
+              <a:t>▶ 스핀을 더 많이 찾은 최종 목록(14개)이 잔차도 가장 작다 — 과적합이 아니라 실제 스핀이라는 증거</a:t>
             </a:r>
           </a:p>
         </p:txBody>
@@ -5194,7 +7508,7 @@
 </p:sld>
 </file>
 
-<file path=ppt/slides/slide8.xml><?xml version="1.0" encoding="utf-8"?>
+<file path=ppt/slides/slide9.xml><?xml version="1.0" encoding="utf-8"?>
 <p:sld xmlns:a="http://schemas.openxmlformats.org/drawingml/2006/main" xmlns:p="http://schemas.openxmlformats.org/presentationml/2006/main" xmlns:r="http://schemas.openxmlformats.org/officeDocument/2006/relationships">
   <p:cSld>
     <p:spTree>
@@ -5212,8 +7526,8 @@
         </p:nvSpPr>
         <p:spPr>
           <a:xfrm>
-            <a:off x="365760" y="137160"/>
-            <a:ext cx="11430000" cy="822960"/>
+            <a:off x="365760" y="109728"/>
+            <a:ext cx="11430000" cy="914400"/>
           </a:xfrm>
           <a:prstGeom prst="rect">
             <a:avLst/>
@@ -5227,7 +7541,7 @@
           <a:lstStyle/>
           <a:p>
             <a:pPr>
-              <a:defRPr sz="2800" b="1"/>
+              <a:defRPr sz="2600" b="1"/>
             </a:pPr>
             <a:r>
               <a:t>NV2: 모델별 피팅 오버레이 + 검출 결합강도</a:t>
@@ -5235,10 +7549,22 @@
           </a:p>
           <a:p>
             <a:pPr>
-              <a:defRPr sz="1300"/>
+              <a:defRPr sz="1200"/>
             </a:pPr>
             <a:r>
               <a:t>CPMG-16 단일 채널 · 강결합 영역 (A⊥ 최대 ~290 kHz)</a:t>
+            </a:r>
+          </a:p>
+          <a:p>
+            <a:pPr>
+              <a:defRPr sz="1400" b="1">
+                <a:solidFill>
+                  <a:srgbClr val="B45000"/>
+                </a:solidFill>
+              </a:defRPr>
+            </a:pPr>
+            <a:r>
+              <a:t>▶ 채널이 하나뿐인 어려운 조건에서도 10개 스핀으로 격렬한 진동 구조를 재현</a:t>
             </a:r>
           </a:p>
         </p:txBody>
@@ -5386,2079 +7712,6 @@
           </a:p>
         </p:txBody>
       </p:sp>
-    </p:spTree>
-  </p:cSld>
-  <p:clrMapOvr>
-    <a:masterClrMapping/>
-  </p:clrMapOvr>
-</p:sld>
-</file>
-
-<file path=ppt/slides/slide9.xml><?xml version="1.0" encoding="utf-8"?>
-<p:sld xmlns:a="http://schemas.openxmlformats.org/drawingml/2006/main" xmlns:p="http://schemas.openxmlformats.org/presentationml/2006/main" xmlns:r="http://schemas.openxmlformats.org/officeDocument/2006/relationships">
-  <p:cSld>
-    <p:spTree>
-      <p:nvGrpSpPr>
-        <p:cNvPr id="1" name=""/>
-        <p:cNvGrpSpPr/>
-        <p:nvPr/>
-      </p:nvGrpSpPr>
-      <p:grpSpPr/>
-      <p:sp>
-        <p:nvSpPr>
-          <p:cNvPr id="2" name="TextBox 1"/>
-          <p:cNvSpPr txBox="1"/>
-          <p:nvPr/>
-        </p:nvSpPr>
-        <p:spPr>
-          <a:xfrm>
-            <a:off x="365760" y="137160"/>
-            <a:ext cx="11430000" cy="822960"/>
-          </a:xfrm>
-          <a:prstGeom prst="rect">
-            <a:avLst/>
-          </a:prstGeom>
-          <a:noFill/>
-        </p:spPr>
-        <p:txBody>
-          <a:bodyPr wrap="none">
-            <a:spAutoFit/>
-          </a:bodyPr>
-          <a:lstStyle/>
-          <a:p>
-            <a:pPr>
-              <a:defRPr sz="2800" b="1"/>
-            </a:pPr>
-            <a:r>
-              <a:t>NV1: 알고리즘별 A-텐서 값 종합표</a:t>
-            </a:r>
-          </a:p>
-          <a:p>
-            <a:pPr>
-              <a:defRPr sz="1300"/>
-            </a:pPr>
-            <a:r>
-              <a:t>값 = (A∥, A⊥) kHz · 윈도우뱅크/PF는 A 위치만 출력 · *앵커 부호는 m_s 브랜치 관례 차이</a:t>
-            </a:r>
-          </a:p>
-        </p:txBody>
-      </p:sp>
-      <p:graphicFrame>
-        <p:nvGraphicFramePr>
-          <p:cNvPr id="3" name="Table 2"/>
-          <p:cNvGraphicFramePr>
-            <a:graphicFrameLocks noGrp="1"/>
-          </p:cNvGraphicFramePr>
-          <p:nvPr/>
-        </p:nvGraphicFramePr>
-        <p:xfrm>
-          <a:off x="274320" y="1143000"/>
-          <a:ext cx="11658600" cy="5394960"/>
-        </p:xfrm>
-        <a:graphic>
-          <a:graphicData uri="http://schemas.openxmlformats.org/drawingml/2006/table">
-            <a:tbl>
-              <a:tblPr firstRow="1" bandRow="1">
-                <a:tableStyleId>{5C22544A-7EE6-4342-B048-85BDC9FD1C3A}</a:tableStyleId>
-              </a:tblPr>
-              <a:tblGrid>
-                <a:gridCol w="1457325"/>
-                <a:gridCol w="1457325"/>
-                <a:gridCol w="1457325"/>
-                <a:gridCol w="1457325"/>
-                <a:gridCol w="1457325"/>
-                <a:gridCol w="1457325"/>
-                <a:gridCol w="1457325"/>
-                <a:gridCol w="1457325"/>
-              </a:tblGrid>
-              <a:tr h="337185">
-                <a:tc>
-                  <a:txBody>
-                    <a:bodyPr/>
-                    <a:lstStyle/>
-                    <a:p>
-                      <a:pPr>
-                        <a:defRPr sz="900" b="1"/>
-                      </a:pPr>
-                      <a:r>
-                        <a:t>앙상블 최종</a:t>
-                      </a:r>
-                    </a:p>
-                  </a:txBody>
-                  <a:tcPr>
-                    <a:solidFill>
-                      <a:srgbClr val="F4CCCC"/>
-                    </a:solidFill>
-                  </a:tcPr>
-                </a:tc>
-                <a:tc>
-                  <a:txBody>
-                    <a:bodyPr/>
-                    <a:lstStyle/>
-                    <a:p>
-                      <a:pPr>
-                        <a:defRPr sz="900" b="1"/>
-                      </a:pPr>
-                      <a:r>
-                        <a:t>ppt 앵커</a:t>
-                      </a:r>
-                    </a:p>
-                  </a:txBody>
-                  <a:tcPr>
-                    <a:solidFill>
-                      <a:srgbClr val="FCE5CD"/>
-                    </a:solidFill>
-                  </a:tcPr>
-                </a:tc>
-                <a:tc>
-                  <a:txBody>
-                    <a:bodyPr/>
-                    <a:lstStyle/>
-                    <a:p>
-                      <a:pPr>
-                        <a:defRPr sz="900" b="1"/>
-                      </a:pPr>
-                      <a:r>
-                        <a:t>2021-MLP</a:t>
-                      </a:r>
-                    </a:p>
-                  </a:txBody>
-                  <a:tcPr>
-                    <a:solidFill>
-                      <a:srgbClr val="D9D9D9"/>
-                    </a:solidFill>
-                  </a:tcPr>
-                </a:tc>
-                <a:tc>
-                  <a:txBody>
-                    <a:bodyPr/>
-                    <a:lstStyle/>
-                    <a:p>
-                      <a:pPr>
-                        <a:defRPr sz="900" b="1"/>
-                      </a:pPr>
-                      <a:r>
-                        <a:t>CNN뱅크</a:t>
-                      </a:r>
-                    </a:p>
-                  </a:txBody>
-                  <a:tcPr>
-                    <a:solidFill>
-                      <a:srgbClr val="D9D9D9"/>
-                    </a:solidFill>
-                  </a:tcPr>
-                </a:tc>
-                <a:tc>
-                  <a:txBody>
-                    <a:bodyPr/>
-                    <a:lstStyle/>
-                    <a:p>
-                      <a:pPr>
-                        <a:defRPr sz="900" b="1"/>
-                      </a:pPr>
-                      <a:r>
-                        <a:t>PF</a:t>
-                      </a:r>
-                    </a:p>
-                  </a:txBody>
-                  <a:tcPr>
-                    <a:solidFill>
-                      <a:srgbClr val="D9D9D9"/>
-                    </a:solidFill>
-                  </a:tcPr>
-                </a:tc>
-                <a:tc>
-                  <a:txBody>
-                    <a:bodyPr/>
-                    <a:lstStyle/>
-                    <a:p>
-                      <a:pPr>
-                        <a:defRPr sz="900" b="1"/>
-                      </a:pPr>
-                      <a:r>
-                        <a:t>SpinDETR</a:t>
-                      </a:r>
-                    </a:p>
-                  </a:txBody>
-                  <a:tcPr>
-                    <a:solidFill>
-                      <a:srgbClr val="D9EAD3"/>
-                    </a:solidFill>
-                  </a:tcPr>
-                </a:tc>
-                <a:tc>
-                  <a:txBody>
-                    <a:bodyPr/>
-                    <a:lstStyle/>
-                    <a:p>
-                      <a:pPr>
-                        <a:defRPr sz="900" b="1"/>
-                      </a:pPr>
-                      <a:r>
-                        <a:t>cdetect-DE</a:t>
-                      </a:r>
-                    </a:p>
-                  </a:txBody>
-                  <a:tcPr>
-                    <a:solidFill>
-                      <a:srgbClr val="CFE2F3"/>
-                    </a:solidFill>
-                  </a:tcPr>
-                </a:tc>
-                <a:tc>
-                  <a:txBody>
-                    <a:bodyPr/>
-                    <a:lstStyle/>
-                    <a:p>
-                      <a:pPr>
-                        <a:defRPr sz="900" b="1"/>
-                      </a:pPr>
-                      <a:r>
-                        <a:t>하이브리드</a:t>
-                      </a:r>
-                    </a:p>
-                  </a:txBody>
-                  <a:tcPr>
-                    <a:solidFill>
-                      <a:srgbClr val="EAD1DC"/>
-                    </a:solidFill>
-                  </a:tcPr>
-                </a:tc>
-              </a:tr>
-              <a:tr h="337185">
-                <a:tc>
-                  <a:txBody>
-                    <a:bodyPr/>
-                    <a:lstStyle/>
-                    <a:p>
-                      <a:pPr>
-                        <a:defRPr sz="900" b="1"/>
-                      </a:pPr>
-                      <a:r>
-                        <a:t>(−87.9, 18)</a:t>
-                      </a:r>
-                    </a:p>
-                  </a:txBody>
-                  <a:tcPr/>
-                </a:tc>
-                <a:tc>
-                  <a:txBody>
-                    <a:bodyPr/>
-                    <a:lstStyle/>
-                    <a:p>
-                      <a:pPr>
-                        <a:defRPr sz="900"/>
-                      </a:pPr>
-                      <a:r>
-                        <a:t>(−88, 47)</a:t>
-                      </a:r>
-                    </a:p>
-                  </a:txBody>
-                  <a:tcPr/>
-                </a:tc>
-                <a:tc>
-                  <a:txBody>
-                    <a:bodyPr/>
-                    <a:lstStyle/>
-                    <a:p>
-                      <a:pPr>
-                        <a:defRPr sz="900"/>
-                      </a:pPr>
-                      <a:r>
-                        <a:t>—</a:t>
-                      </a:r>
-                    </a:p>
-                  </a:txBody>
-                  <a:tcPr/>
-                </a:tc>
-                <a:tc>
-                  <a:txBody>
-                    <a:bodyPr/>
-                    <a:lstStyle/>
-                    <a:p>
-                      <a:pPr>
-                        <a:defRPr sz="900"/>
-                      </a:pPr>
-                      <a:r>
-                        <a:t>—</a:t>
-                      </a:r>
-                    </a:p>
-                  </a:txBody>
-                  <a:tcPr/>
-                </a:tc>
-                <a:tc>
-                  <a:txBody>
-                    <a:bodyPr/>
-                    <a:lstStyle/>
-                    <a:p>
-                      <a:pPr>
-                        <a:defRPr sz="900"/>
-                      </a:pPr>
-                      <a:r>
-                        <a:t>−86</a:t>
-                      </a:r>
-                    </a:p>
-                  </a:txBody>
-                  <a:tcPr/>
-                </a:tc>
-                <a:tc>
-                  <a:txBody>
-                    <a:bodyPr/>
-                    <a:lstStyle/>
-                    <a:p>
-                      <a:pPr>
-                        <a:defRPr sz="900"/>
-                      </a:pPr>
-                      <a:r>
-                        <a:t>—</a:t>
-                      </a:r>
-                    </a:p>
-                  </a:txBody>
-                  <a:tcPr/>
-                </a:tc>
-                <a:tc>
-                  <a:txBody>
-                    <a:bodyPr/>
-                    <a:lstStyle/>
-                    <a:p>
-                      <a:pPr>
-                        <a:defRPr sz="900"/>
-                      </a:pPr>
-                      <a:r>
-                        <a:t>(−87.6, 19)</a:t>
-                      </a:r>
-                    </a:p>
-                  </a:txBody>
-                  <a:tcPr/>
-                </a:tc>
-                <a:tc>
-                  <a:txBody>
-                    <a:bodyPr/>
-                    <a:lstStyle/>
-                    <a:p>
-                      <a:pPr>
-                        <a:defRPr sz="900"/>
-                      </a:pPr>
-                      <a:r>
-                        <a:t>—</a:t>
-                      </a:r>
-                    </a:p>
-                  </a:txBody>
-                  <a:tcPr/>
-                </a:tc>
-              </a:tr>
-              <a:tr h="337185">
-                <a:tc>
-                  <a:txBody>
-                    <a:bodyPr/>
-                    <a:lstStyle/>
-                    <a:p>
-                      <a:pPr>
-                        <a:defRPr sz="900" b="1"/>
-                      </a:pPr>
-                      <a:r>
-                        <a:t>(−18.8, 16)</a:t>
-                      </a:r>
-                    </a:p>
-                  </a:txBody>
-                  <a:tcPr/>
-                </a:tc>
-                <a:tc>
-                  <a:txBody>
-                    <a:bodyPr/>
-                    <a:lstStyle/>
-                    <a:p>
-                      <a:pPr>
-                        <a:defRPr sz="900"/>
-                      </a:pPr>
-                      <a:r>
-                        <a:t>—</a:t>
-                      </a:r>
-                    </a:p>
-                  </a:txBody>
-                  <a:tcPr/>
-                </a:tc>
-                <a:tc>
-                  <a:txBody>
-                    <a:bodyPr/>
-                    <a:lstStyle/>
-                    <a:p>
-                      <a:pPr>
-                        <a:defRPr sz="900"/>
-                      </a:pPr>
-                      <a:r>
-                        <a:t>−20</a:t>
-                      </a:r>
-                    </a:p>
-                  </a:txBody>
-                  <a:tcPr/>
-                </a:tc>
-                <a:tc>
-                  <a:txBody>
-                    <a:bodyPr/>
-                    <a:lstStyle/>
-                    <a:p>
-                      <a:pPr>
-                        <a:defRPr sz="900"/>
-                      </a:pPr>
-                      <a:r>
-                        <a:t>−16</a:t>
-                      </a:r>
-                    </a:p>
-                  </a:txBody>
-                  <a:tcPr/>
-                </a:tc>
-                <a:tc>
-                  <a:txBody>
-                    <a:bodyPr/>
-                    <a:lstStyle/>
-                    <a:p>
-                      <a:pPr>
-                        <a:defRPr sz="900"/>
-                      </a:pPr>
-                      <a:r>
-                        <a:t>−16</a:t>
-                      </a:r>
-                    </a:p>
-                  </a:txBody>
-                  <a:tcPr/>
-                </a:tc>
-                <a:tc>
-                  <a:txBody>
-                    <a:bodyPr/>
-                    <a:lstStyle/>
-                    <a:p>
-                      <a:pPr>
-                        <a:defRPr sz="900"/>
-                      </a:pPr>
-                      <a:r>
-                        <a:t>(−15.5, 21)</a:t>
-                      </a:r>
-                    </a:p>
-                  </a:txBody>
-                  <a:tcPr/>
-                </a:tc>
-                <a:tc>
-                  <a:txBody>
-                    <a:bodyPr/>
-                    <a:lstStyle/>
-                    <a:p>
-                      <a:pPr>
-                        <a:defRPr sz="900"/>
-                      </a:pPr>
-                      <a:r>
-                        <a:t>—</a:t>
-                      </a:r>
-                    </a:p>
-                  </a:txBody>
-                  <a:tcPr/>
-                </a:tc>
-                <a:tc>
-                  <a:txBody>
-                    <a:bodyPr/>
-                    <a:lstStyle/>
-                    <a:p>
-                      <a:pPr>
-                        <a:defRPr sz="900"/>
-                      </a:pPr>
-                      <a:r>
-                        <a:t>(−19.0, 16)</a:t>
-                      </a:r>
-                    </a:p>
-                  </a:txBody>
-                  <a:tcPr/>
-                </a:tc>
-              </a:tr>
-              <a:tr h="337185">
-                <a:tc>
-                  <a:txBody>
-                    <a:bodyPr/>
-                    <a:lstStyle/>
-                    <a:p>
-                      <a:pPr>
-                        <a:defRPr sz="900" b="1"/>
-                      </a:pPr>
-                      <a:r>
-                        <a:t>(−11.5, 14)</a:t>
-                      </a:r>
-                    </a:p>
-                  </a:txBody>
-                  <a:tcPr/>
-                </a:tc>
-                <a:tc>
-                  <a:txBody>
-                    <a:bodyPr/>
-                    <a:lstStyle/>
-                    <a:p>
-                      <a:pPr>
-                        <a:defRPr sz="900"/>
-                      </a:pPr>
-                      <a:r>
-                        <a:t>—</a:t>
-                      </a:r>
-                    </a:p>
-                  </a:txBody>
-                  <a:tcPr/>
-                </a:tc>
-                <a:tc>
-                  <a:txBody>
-                    <a:bodyPr/>
-                    <a:lstStyle/>
-                    <a:p>
-                      <a:pPr>
-                        <a:defRPr sz="900"/>
-                      </a:pPr>
-                      <a:r>
-                        <a:t>—</a:t>
-                      </a:r>
-                    </a:p>
-                  </a:txBody>
-                  <a:tcPr/>
-                </a:tc>
-                <a:tc>
-                  <a:txBody>
-                    <a:bodyPr/>
-                    <a:lstStyle/>
-                    <a:p>
-                      <a:pPr>
-                        <a:defRPr sz="900"/>
-                      </a:pPr>
-                      <a:r>
-                        <a:t>−8</a:t>
-                      </a:r>
-                    </a:p>
-                  </a:txBody>
-                  <a:tcPr/>
-                </a:tc>
-                <a:tc>
-                  <a:txBody>
-                    <a:bodyPr/>
-                    <a:lstStyle/>
-                    <a:p>
-                      <a:pPr>
-                        <a:defRPr sz="900"/>
-                      </a:pPr>
-                      <a:r>
-                        <a:t>—</a:t>
-                      </a:r>
-                    </a:p>
-                  </a:txBody>
-                  <a:tcPr/>
-                </a:tc>
-                <a:tc>
-                  <a:txBody>
-                    <a:bodyPr/>
-                    <a:lstStyle/>
-                    <a:p>
-                      <a:pPr>
-                        <a:defRPr sz="900"/>
-                      </a:pPr>
-                      <a:r>
-                        <a:t>—</a:t>
-                      </a:r>
-                    </a:p>
-                  </a:txBody>
-                  <a:tcPr/>
-                </a:tc>
-                <a:tc>
-                  <a:txBody>
-                    <a:bodyPr/>
-                    <a:lstStyle/>
-                    <a:p>
-                      <a:pPr>
-                        <a:defRPr sz="900"/>
-                      </a:pPr>
-                      <a:r>
-                        <a:t>—</a:t>
-                      </a:r>
-                    </a:p>
-                  </a:txBody>
-                  <a:tcPr/>
-                </a:tc>
-                <a:tc>
-                  <a:txBody>
-                    <a:bodyPr/>
-                    <a:lstStyle/>
-                    <a:p>
-                      <a:pPr>
-                        <a:defRPr sz="900"/>
-                      </a:pPr>
-                      <a:r>
-                        <a:t>(−13.9, 16)</a:t>
-                      </a:r>
-                    </a:p>
-                  </a:txBody>
-                  <a:tcPr/>
-                </a:tc>
-              </a:tr>
-              <a:tr h="337185">
-                <a:tc>
-                  <a:txBody>
-                    <a:bodyPr/>
-                    <a:lstStyle/>
-                    <a:p>
-                      <a:pPr>
-                        <a:defRPr sz="900" b="1"/>
-                      </a:pPr>
-                      <a:r>
-                        <a:t>(−5.1, 22)</a:t>
-                      </a:r>
-                    </a:p>
-                  </a:txBody>
-                  <a:tcPr/>
-                </a:tc>
-                <a:tc>
-                  <a:txBody>
-                    <a:bodyPr/>
-                    <a:lstStyle/>
-                    <a:p>
-                      <a:pPr>
-                        <a:defRPr sz="900"/>
-                      </a:pPr>
-                      <a:r>
-                        <a:t>(−5, 35)</a:t>
-                      </a:r>
-                    </a:p>
-                  </a:txBody>
-                  <a:tcPr/>
-                </a:tc>
-                <a:tc>
-                  <a:txBody>
-                    <a:bodyPr/>
-                    <a:lstStyle/>
-                    <a:p>
-                      <a:pPr>
-                        <a:defRPr sz="900"/>
-                      </a:pPr>
-                      <a:r>
-                        <a:t>−6</a:t>
-                      </a:r>
-                    </a:p>
-                  </a:txBody>
-                  <a:tcPr/>
-                </a:tc>
-                <a:tc>
-                  <a:txBody>
-                    <a:bodyPr/>
-                    <a:lstStyle/>
-                    <a:p>
-                      <a:pPr>
-                        <a:defRPr sz="900"/>
-                      </a:pPr>
-                      <a:r>
-                        <a:t>−8</a:t>
-                      </a:r>
-                    </a:p>
-                  </a:txBody>
-                  <a:tcPr/>
-                </a:tc>
-                <a:tc>
-                  <a:txBody>
-                    <a:bodyPr/>
-                    <a:lstStyle/>
-                    <a:p>
-                      <a:pPr>
-                        <a:defRPr sz="900"/>
-                      </a:pPr>
-                      <a:r>
-                        <a:t>−6</a:t>
-                      </a:r>
-                    </a:p>
-                  </a:txBody>
-                  <a:tcPr/>
-                </a:tc>
-                <a:tc>
-                  <a:txBody>
-                    <a:bodyPr/>
-                    <a:lstStyle/>
-                    <a:p>
-                      <a:pPr>
-                        <a:defRPr sz="900"/>
-                      </a:pPr>
-                      <a:r>
-                        <a:t>(−6.2, 29)</a:t>
-                      </a:r>
-                    </a:p>
-                  </a:txBody>
-                  <a:tcPr/>
-                </a:tc>
-                <a:tc>
-                  <a:txBody>
-                    <a:bodyPr/>
-                    <a:lstStyle/>
-                    <a:p>
-                      <a:pPr>
-                        <a:defRPr sz="900"/>
-                      </a:pPr>
-                      <a:r>
-                        <a:t>(−5.6, 26)</a:t>
-                      </a:r>
-                    </a:p>
-                  </a:txBody>
-                  <a:tcPr/>
-                </a:tc>
-                <a:tc>
-                  <a:txBody>
-                    <a:bodyPr/>
-                    <a:lstStyle/>
-                    <a:p>
-                      <a:pPr>
-                        <a:defRPr sz="900"/>
-                      </a:pPr>
-                      <a:r>
-                        <a:t>(−5.1, 23)</a:t>
-                      </a:r>
-                    </a:p>
-                  </a:txBody>
-                  <a:tcPr/>
-                </a:tc>
-              </a:tr>
-              <a:tr h="337185">
-                <a:tc>
-                  <a:txBody>
-                    <a:bodyPr/>
-                    <a:lstStyle/>
-                    <a:p>
-                      <a:pPr>
-                        <a:defRPr sz="900" b="1"/>
-                      </a:pPr>
-                      <a:r>
-                        <a:t>(+0.6, 17)</a:t>
-                      </a:r>
-                    </a:p>
-                  </a:txBody>
-                  <a:tcPr/>
-                </a:tc>
-                <a:tc>
-                  <a:txBody>
-                    <a:bodyPr/>
-                    <a:lstStyle/>
-                    <a:p>
-                      <a:pPr>
-                        <a:defRPr sz="900"/>
-                      </a:pPr>
-                      <a:r>
-                        <a:t>—</a:t>
-                      </a:r>
-                    </a:p>
-                  </a:txBody>
-                  <a:tcPr/>
-                </a:tc>
-                <a:tc>
-                  <a:txBody>
-                    <a:bodyPr/>
-                    <a:lstStyle/>
-                    <a:p>
-                      <a:pPr>
-                        <a:defRPr sz="900"/>
-                      </a:pPr>
-                      <a:r>
-                        <a:t>+2</a:t>
-                      </a:r>
-                    </a:p>
-                  </a:txBody>
-                  <a:tcPr/>
-                </a:tc>
-                <a:tc>
-                  <a:txBody>
-                    <a:bodyPr/>
-                    <a:lstStyle/>
-                    <a:p>
-                      <a:pPr>
-                        <a:defRPr sz="900"/>
-                      </a:pPr>
-                      <a:r>
-                        <a:t>—</a:t>
-                      </a:r>
-                    </a:p>
-                  </a:txBody>
-                  <a:tcPr/>
-                </a:tc>
-                <a:tc>
-                  <a:txBody>
-                    <a:bodyPr/>
-                    <a:lstStyle/>
-                    <a:p>
-                      <a:pPr>
-                        <a:defRPr sz="900"/>
-                      </a:pPr>
-                      <a:r>
-                        <a:t>+2</a:t>
-                      </a:r>
-                    </a:p>
-                  </a:txBody>
-                  <a:tcPr/>
-                </a:tc>
-                <a:tc>
-                  <a:txBody>
-                    <a:bodyPr/>
-                    <a:lstStyle/>
-                    <a:p>
-                      <a:pPr>
-                        <a:defRPr sz="900"/>
-                      </a:pPr>
-                      <a:r>
-                        <a:t>(−2.2, 23)</a:t>
-                      </a:r>
-                    </a:p>
-                  </a:txBody>
-                  <a:tcPr/>
-                </a:tc>
-                <a:tc>
-                  <a:txBody>
-                    <a:bodyPr/>
-                    <a:lstStyle/>
-                    <a:p>
-                      <a:pPr>
-                        <a:defRPr sz="900"/>
-                      </a:pPr>
-                      <a:r>
-                        <a:t>(+3.3, 30)</a:t>
-                      </a:r>
-                    </a:p>
-                  </a:txBody>
-                  <a:tcPr/>
-                </a:tc>
-                <a:tc>
-                  <a:txBody>
-                    <a:bodyPr/>
-                    <a:lstStyle/>
-                    <a:p>
-                      <a:pPr>
-                        <a:defRPr sz="900"/>
-                      </a:pPr>
-                      <a:r>
-                        <a:t>(+1.1, 21)</a:t>
-                      </a:r>
-                    </a:p>
-                  </a:txBody>
-                  <a:tcPr/>
-                </a:tc>
-              </a:tr>
-              <a:tr h="337185">
-                <a:tc>
-                  <a:txBody>
-                    <a:bodyPr/>
-                    <a:lstStyle/>
-                    <a:p>
-                      <a:pPr>
-                        <a:defRPr sz="900" b="1"/>
-                      </a:pPr>
-                      <a:r>
-                        <a:t>(+4.0, 26)</a:t>
-                      </a:r>
-                    </a:p>
-                  </a:txBody>
-                  <a:tcPr/>
-                </a:tc>
-                <a:tc>
-                  <a:txBody>
-                    <a:bodyPr/>
-                    <a:lstStyle/>
-                    <a:p>
-                      <a:pPr>
-                        <a:defRPr sz="900"/>
-                      </a:pPr>
-                      <a:r>
-                        <a:t>—</a:t>
-                      </a:r>
-                    </a:p>
-                  </a:txBody>
-                  <a:tcPr/>
-                </a:tc>
-                <a:tc>
-                  <a:txBody>
-                    <a:bodyPr/>
-                    <a:lstStyle/>
-                    <a:p>
-                      <a:pPr>
-                        <a:defRPr sz="900"/>
-                      </a:pPr>
-                      <a:r>
-                        <a:t>+2</a:t>
-                      </a:r>
-                    </a:p>
-                  </a:txBody>
-                  <a:tcPr/>
-                </a:tc>
-                <a:tc>
-                  <a:txBody>
-                    <a:bodyPr/>
-                    <a:lstStyle/>
-                    <a:p>
-                      <a:pPr>
-                        <a:defRPr sz="900"/>
-                      </a:pPr>
-                      <a:r>
-                        <a:t>+4</a:t>
-                      </a:r>
-                    </a:p>
-                  </a:txBody>
-                  <a:tcPr/>
-                </a:tc>
-                <a:tc>
-                  <a:txBody>
-                    <a:bodyPr/>
-                    <a:lstStyle/>
-                    <a:p>
-                      <a:pPr>
-                        <a:defRPr sz="900"/>
-                      </a:pPr>
-                      <a:r>
-                        <a:t>+2</a:t>
-                      </a:r>
-                    </a:p>
-                  </a:txBody>
-                  <a:tcPr/>
-                </a:tc>
-                <a:tc>
-                  <a:txBody>
-                    <a:bodyPr/>
-                    <a:lstStyle/>
-                    <a:p>
-                      <a:pPr>
-                        <a:defRPr sz="900"/>
-                      </a:pPr>
-                      <a:r>
-                        <a:t>—</a:t>
-                      </a:r>
-                    </a:p>
-                  </a:txBody>
-                  <a:tcPr/>
-                </a:tc>
-                <a:tc>
-                  <a:txBody>
-                    <a:bodyPr/>
-                    <a:lstStyle/>
-                    <a:p>
-                      <a:pPr>
-                        <a:defRPr sz="900"/>
-                      </a:pPr>
-                      <a:r>
-                        <a:t>(+3.3, 30)</a:t>
-                      </a:r>
-                    </a:p>
-                  </a:txBody>
-                  <a:tcPr/>
-                </a:tc>
-                <a:tc>
-                  <a:txBody>
-                    <a:bodyPr/>
-                    <a:lstStyle/>
-                    <a:p>
-                      <a:pPr>
-                        <a:defRPr sz="900"/>
-                      </a:pPr>
-                      <a:r>
-                        <a:t>(+4.0, 27)</a:t>
-                      </a:r>
-                    </a:p>
-                  </a:txBody>
-                  <a:tcPr/>
-                </a:tc>
-              </a:tr>
-              <a:tr h="337185">
-                <a:tc>
-                  <a:txBody>
-                    <a:bodyPr/>
-                    <a:lstStyle/>
-                    <a:p>
-                      <a:pPr>
-                        <a:defRPr sz="900" b="1"/>
-                      </a:pPr>
-                      <a:r>
-                        <a:t>(+8.4, 28)</a:t>
-                      </a:r>
-                    </a:p>
-                  </a:txBody>
-                  <a:tcPr/>
-                </a:tc>
-                <a:tc>
-                  <a:txBody>
-                    <a:bodyPr/>
-                    <a:lstStyle/>
-                    <a:p>
-                      <a:pPr>
-                        <a:defRPr sz="900"/>
-                      </a:pPr>
-                      <a:r>
-                        <a:t>(+8, 31)</a:t>
-                      </a:r>
-                    </a:p>
-                  </a:txBody>
-                  <a:tcPr/>
-                </a:tc>
-                <a:tc>
-                  <a:txBody>
-                    <a:bodyPr/>
-                    <a:lstStyle/>
-                    <a:p>
-                      <a:pPr>
-                        <a:defRPr sz="900"/>
-                      </a:pPr>
-                      <a:r>
-                        <a:t>+12</a:t>
-                      </a:r>
-                    </a:p>
-                  </a:txBody>
-                  <a:tcPr/>
-                </a:tc>
-                <a:tc>
-                  <a:txBody>
-                    <a:bodyPr/>
-                    <a:lstStyle/>
-                    <a:p>
-                      <a:pPr>
-                        <a:defRPr sz="900"/>
-                      </a:pPr>
-                      <a:r>
-                        <a:t>+4</a:t>
-                      </a:r>
-                    </a:p>
-                  </a:txBody>
-                  <a:tcPr/>
-                </a:tc>
-                <a:tc>
-                  <a:txBody>
-                    <a:bodyPr/>
-                    <a:lstStyle/>
-                    <a:p>
-                      <a:pPr>
-                        <a:defRPr sz="900"/>
-                      </a:pPr>
-                      <a:r>
-                        <a:t>+8</a:t>
-                      </a:r>
-                    </a:p>
-                  </a:txBody>
-                  <a:tcPr/>
-                </a:tc>
-                <a:tc>
-                  <a:txBody>
-                    <a:bodyPr/>
-                    <a:lstStyle/>
-                    <a:p>
-                      <a:pPr>
-                        <a:defRPr sz="900"/>
-                      </a:pPr>
-                      <a:r>
-                        <a:t>(+7.4, 29)</a:t>
-                      </a:r>
-                    </a:p>
-                  </a:txBody>
-                  <a:tcPr/>
-                </a:tc>
-                <a:tc>
-                  <a:txBody>
-                    <a:bodyPr/>
-                    <a:lstStyle/>
-                    <a:p>
-                      <a:pPr>
-                        <a:defRPr sz="900"/>
-                      </a:pPr>
-                      <a:r>
-                        <a:t>(+9.2, 31)</a:t>
-                      </a:r>
-                    </a:p>
-                  </a:txBody>
-                  <a:tcPr/>
-                </a:tc>
-                <a:tc>
-                  <a:txBody>
-                    <a:bodyPr/>
-                    <a:lstStyle/>
-                    <a:p>
-                      <a:pPr>
-                        <a:defRPr sz="900"/>
-                      </a:pPr>
-                      <a:r>
-                        <a:t>(+8.5, 30)</a:t>
-                      </a:r>
-                    </a:p>
-                  </a:txBody>
-                  <a:tcPr/>
-                </a:tc>
-              </a:tr>
-              <a:tr h="337185">
-                <a:tc>
-                  <a:txBody>
-                    <a:bodyPr/>
-                    <a:lstStyle/>
-                    <a:p>
-                      <a:pPr>
-                        <a:defRPr sz="900" b="1"/>
-                      </a:pPr>
-                      <a:r>
-                        <a:t>(+14.2, 22)</a:t>
-                      </a:r>
-                    </a:p>
-                  </a:txBody>
-                  <a:tcPr/>
-                </a:tc>
-                <a:tc>
-                  <a:txBody>
-                    <a:bodyPr/>
-                    <a:lstStyle/>
-                    <a:p>
-                      <a:pPr>
-                        <a:defRPr sz="900"/>
-                      </a:pPr>
-                      <a:r>
-                        <a:t>—</a:t>
-                      </a:r>
-                    </a:p>
-                  </a:txBody>
-                  <a:tcPr/>
-                </a:tc>
-                <a:tc>
-                  <a:txBody>
-                    <a:bodyPr/>
-                    <a:lstStyle/>
-                    <a:p>
-                      <a:pPr>
-                        <a:defRPr sz="900"/>
-                      </a:pPr>
-                      <a:r>
-                        <a:t>+12</a:t>
-                      </a:r>
-                    </a:p>
-                  </a:txBody>
-                  <a:tcPr/>
-                </a:tc>
-                <a:tc>
-                  <a:txBody>
-                    <a:bodyPr/>
-                    <a:lstStyle/>
-                    <a:p>
-                      <a:pPr>
-                        <a:defRPr sz="900"/>
-                      </a:pPr>
-                      <a:r>
-                        <a:t>—</a:t>
-                      </a:r>
-                    </a:p>
-                  </a:txBody>
-                  <a:tcPr/>
-                </a:tc>
-                <a:tc>
-                  <a:txBody>
-                    <a:bodyPr/>
-                    <a:lstStyle/>
-                    <a:p>
-                      <a:pPr>
-                        <a:defRPr sz="900"/>
-                      </a:pPr>
-                      <a:r>
-                        <a:t>+14</a:t>
-                      </a:r>
-                    </a:p>
-                  </a:txBody>
-                  <a:tcPr/>
-                </a:tc>
-                <a:tc>
-                  <a:txBody>
-                    <a:bodyPr/>
-                    <a:lstStyle/>
-                    <a:p>
-                      <a:pPr>
-                        <a:defRPr sz="900"/>
-                      </a:pPr>
-                      <a:r>
-                        <a:t>(+13.1, 25)</a:t>
-                      </a:r>
-                    </a:p>
-                  </a:txBody>
-                  <a:tcPr/>
-                </a:tc>
-                <a:tc>
-                  <a:txBody>
-                    <a:bodyPr/>
-                    <a:lstStyle/>
-                    <a:p>
-                      <a:pPr>
-                        <a:defRPr sz="900"/>
-                      </a:pPr>
-                      <a:r>
-                        <a:t>—</a:t>
-                      </a:r>
-                    </a:p>
-                  </a:txBody>
-                  <a:tcPr/>
-                </a:tc>
-                <a:tc>
-                  <a:txBody>
-                    <a:bodyPr/>
-                    <a:lstStyle/>
-                    <a:p>
-                      <a:pPr>
-                        <a:defRPr sz="900"/>
-                      </a:pPr>
-                      <a:r>
-                        <a:t>(+14.5, 25)</a:t>
-                      </a:r>
-                    </a:p>
-                  </a:txBody>
-                  <a:tcPr/>
-                </a:tc>
-              </a:tr>
-              <a:tr h="337185">
-                <a:tc>
-                  <a:txBody>
-                    <a:bodyPr/>
-                    <a:lstStyle/>
-                    <a:p>
-                      <a:pPr>
-                        <a:defRPr sz="900" b="1"/>
-                      </a:pPr>
-                      <a:r>
-                        <a:t>(+24.3, 20)</a:t>
-                      </a:r>
-                    </a:p>
-                  </a:txBody>
-                  <a:tcPr/>
-                </a:tc>
-                <a:tc>
-                  <a:txBody>
-                    <a:bodyPr/>
-                    <a:lstStyle/>
-                    <a:p>
-                      <a:pPr>
-                        <a:defRPr sz="900"/>
-                      </a:pPr>
-                      <a:r>
-                        <a:t>—</a:t>
-                      </a:r>
-                    </a:p>
-                  </a:txBody>
-                  <a:tcPr/>
-                </a:tc>
-                <a:tc>
-                  <a:txBody>
-                    <a:bodyPr/>
-                    <a:lstStyle/>
-                    <a:p>
-                      <a:pPr>
-                        <a:defRPr sz="900"/>
-                      </a:pPr>
-                      <a:r>
-                        <a:t>+22</a:t>
-                      </a:r>
-                    </a:p>
-                  </a:txBody>
-                  <a:tcPr/>
-                </a:tc>
-                <a:tc>
-                  <a:txBody>
-                    <a:bodyPr/>
-                    <a:lstStyle/>
-                    <a:p>
-                      <a:pPr>
-                        <a:defRPr sz="900"/>
-                      </a:pPr>
-                      <a:r>
-                        <a:t>+28</a:t>
-                      </a:r>
-                    </a:p>
-                  </a:txBody>
-                  <a:tcPr/>
-                </a:tc>
-                <a:tc>
-                  <a:txBody>
-                    <a:bodyPr/>
-                    <a:lstStyle/>
-                    <a:p>
-                      <a:pPr>
-                        <a:defRPr sz="900"/>
-                      </a:pPr>
-                      <a:r>
-                        <a:t>+22</a:t>
-                      </a:r>
-                    </a:p>
-                  </a:txBody>
-                  <a:tcPr/>
-                </a:tc>
-                <a:tc>
-                  <a:txBody>
-                    <a:bodyPr/>
-                    <a:lstStyle/>
-                    <a:p>
-                      <a:pPr>
-                        <a:defRPr sz="900"/>
-                      </a:pPr>
-                      <a:r>
-                        <a:t>—</a:t>
-                      </a:r>
-                    </a:p>
-                  </a:txBody>
-                  <a:tcPr/>
-                </a:tc>
-                <a:tc>
-                  <a:txBody>
-                    <a:bodyPr/>
-                    <a:lstStyle/>
-                    <a:p>
-                      <a:pPr>
-                        <a:defRPr sz="900"/>
-                      </a:pPr>
-                      <a:r>
-                        <a:t>(+23.7, 24)</a:t>
-                      </a:r>
-                    </a:p>
-                  </a:txBody>
-                  <a:tcPr/>
-                </a:tc>
-                <a:tc>
-                  <a:txBody>
-                    <a:bodyPr/>
-                    <a:lstStyle/>
-                    <a:p>
-                      <a:pPr>
-                        <a:defRPr sz="900"/>
-                      </a:pPr>
-                      <a:r>
-                        <a:t>—</a:t>
-                      </a:r>
-                    </a:p>
-                  </a:txBody>
-                  <a:tcPr/>
-                </a:tc>
-              </a:tr>
-              <a:tr h="337185">
-                <a:tc>
-                  <a:txBody>
-                    <a:bodyPr/>
-                    <a:lstStyle/>
-                    <a:p>
-                      <a:pPr>
-                        <a:defRPr sz="900" b="1"/>
-                      </a:pPr>
-                      <a:r>
-                        <a:t>(+39.0, 28)</a:t>
-                      </a:r>
-                    </a:p>
-                  </a:txBody>
-                  <a:tcPr/>
-                </a:tc>
-                <a:tc>
-                  <a:txBody>
-                    <a:bodyPr/>
-                    <a:lstStyle/>
-                    <a:p>
-                      <a:pPr>
-                        <a:defRPr sz="900"/>
-                      </a:pPr>
-                      <a:r>
-                        <a:t>(−38, 37)*</a:t>
-                      </a:r>
-                    </a:p>
-                  </a:txBody>
-                  <a:tcPr/>
-                </a:tc>
-                <a:tc>
-                  <a:txBody>
-                    <a:bodyPr/>
-                    <a:lstStyle/>
-                    <a:p>
-                      <a:pPr>
-                        <a:defRPr sz="900"/>
-                      </a:pPr>
-                      <a:r>
-                        <a:t>+42</a:t>
-                      </a:r>
-                    </a:p>
-                  </a:txBody>
-                  <a:tcPr/>
-                </a:tc>
-                <a:tc>
-                  <a:txBody>
-                    <a:bodyPr/>
-                    <a:lstStyle/>
-                    <a:p>
-                      <a:pPr>
-                        <a:defRPr sz="900"/>
-                      </a:pPr>
-                      <a:r>
-                        <a:t>+42</a:t>
-                      </a:r>
-                    </a:p>
-                  </a:txBody>
-                  <a:tcPr/>
-                </a:tc>
-                <a:tc>
-                  <a:txBody>
-                    <a:bodyPr/>
-                    <a:lstStyle/>
-                    <a:p>
-                      <a:pPr>
-                        <a:defRPr sz="900"/>
-                      </a:pPr>
-                      <a:r>
-                        <a:t>+38/40</a:t>
-                      </a:r>
-                    </a:p>
-                  </a:txBody>
-                  <a:tcPr/>
-                </a:tc>
-                <a:tc>
-                  <a:txBody>
-                    <a:bodyPr/>
-                    <a:lstStyle/>
-                    <a:p>
-                      <a:pPr>
-                        <a:defRPr sz="900"/>
-                      </a:pPr>
-                      <a:r>
-                        <a:t>(+37.6, 27)</a:t>
-                      </a:r>
-                    </a:p>
-                  </a:txBody>
-                  <a:tcPr/>
-                </a:tc>
-                <a:tc>
-                  <a:txBody>
-                    <a:bodyPr/>
-                    <a:lstStyle/>
-                    <a:p>
-                      <a:pPr>
-                        <a:defRPr sz="900"/>
-                      </a:pPr>
-                      <a:r>
-                        <a:t>(+40.7, 33)</a:t>
-                      </a:r>
-                    </a:p>
-                  </a:txBody>
-                  <a:tcPr/>
-                </a:tc>
-                <a:tc>
-                  <a:txBody>
-                    <a:bodyPr/>
-                    <a:lstStyle/>
-                    <a:p>
-                      <a:pPr>
-                        <a:defRPr sz="900"/>
-                      </a:pPr>
-                      <a:r>
-                        <a:t>(+37.5, 28)</a:t>
-                      </a:r>
-                    </a:p>
-                  </a:txBody>
-                  <a:tcPr/>
-                </a:tc>
-              </a:tr>
-              <a:tr h="337185">
-                <a:tc>
-                  <a:txBody>
-                    <a:bodyPr/>
-                    <a:lstStyle/>
-                    <a:p>
-                      <a:pPr>
-                        <a:defRPr sz="900" b="1"/>
-                      </a:pPr>
-                      <a:r>
-                        <a:t>(+48.0, 25)</a:t>
-                      </a:r>
-                    </a:p>
-                  </a:txBody>
-                  <a:tcPr/>
-                </a:tc>
-                <a:tc>
-                  <a:txBody>
-                    <a:bodyPr/>
-                    <a:lstStyle/>
-                    <a:p>
-                      <a:pPr>
-                        <a:defRPr sz="900"/>
-                      </a:pPr>
-                      <a:r>
-                        <a:t>—</a:t>
-                      </a:r>
-                    </a:p>
-                  </a:txBody>
-                  <a:tcPr/>
-                </a:tc>
-                <a:tc>
-                  <a:txBody>
-                    <a:bodyPr/>
-                    <a:lstStyle/>
-                    <a:p>
-                      <a:pPr>
-                        <a:defRPr sz="900"/>
-                      </a:pPr>
-                      <a:r>
-                        <a:t>+46</a:t>
-                      </a:r>
-                    </a:p>
-                  </a:txBody>
-                  <a:tcPr/>
-                </a:tc>
-                <a:tc>
-                  <a:txBody>
-                    <a:bodyPr/>
-                    <a:lstStyle/>
-                    <a:p>
-                      <a:pPr>
-                        <a:defRPr sz="900"/>
-                      </a:pPr>
-                      <a:r>
-                        <a:t>—</a:t>
-                      </a:r>
-                    </a:p>
-                  </a:txBody>
-                  <a:tcPr/>
-                </a:tc>
-                <a:tc>
-                  <a:txBody>
-                    <a:bodyPr/>
-                    <a:lstStyle/>
-                    <a:p>
-                      <a:pPr>
-                        <a:defRPr sz="900"/>
-                      </a:pPr>
-                      <a:r>
-                        <a:t>—</a:t>
-                      </a:r>
-                    </a:p>
-                  </a:txBody>
-                  <a:tcPr/>
-                </a:tc>
-                <a:tc>
-                  <a:txBody>
-                    <a:bodyPr/>
-                    <a:lstStyle/>
-                    <a:p>
-                      <a:pPr>
-                        <a:defRPr sz="900"/>
-                      </a:pPr>
-                      <a:r>
-                        <a:t>—</a:t>
-                      </a:r>
-                    </a:p>
-                  </a:txBody>
-                  <a:tcPr/>
-                </a:tc>
-                <a:tc>
-                  <a:txBody>
-                    <a:bodyPr/>
-                    <a:lstStyle/>
-                    <a:p>
-                      <a:pPr>
-                        <a:defRPr sz="900"/>
-                      </a:pPr>
-                      <a:r>
-                        <a:t>—</a:t>
-                      </a:r>
-                    </a:p>
-                  </a:txBody>
-                  <a:tcPr/>
-                </a:tc>
-                <a:tc>
-                  <a:txBody>
-                    <a:bodyPr/>
-                    <a:lstStyle/>
-                    <a:p>
-                      <a:pPr>
-                        <a:defRPr sz="900"/>
-                      </a:pPr>
-                      <a:r>
-                        <a:t>(+45.0, 33)</a:t>
-                      </a:r>
-                    </a:p>
-                  </a:txBody>
-                  <a:tcPr/>
-                </a:tc>
-              </a:tr>
-              <a:tr h="337185">
-                <a:tc>
-                  <a:txBody>
-                    <a:bodyPr/>
-                    <a:lstStyle/>
-                    <a:p>
-                      <a:pPr>
-                        <a:defRPr sz="900" b="1"/>
-                      </a:pPr>
-                      <a:r>
-                        <a:t>(+65.6, 28)</a:t>
-                      </a:r>
-                    </a:p>
-                  </a:txBody>
-                  <a:tcPr/>
-                </a:tc>
-                <a:tc>
-                  <a:txBody>
-                    <a:bodyPr/>
-                    <a:lstStyle/>
-                    <a:p>
-                      <a:pPr>
-                        <a:defRPr sz="900"/>
-                      </a:pPr>
-                      <a:r>
-                        <a:t>—</a:t>
-                      </a:r>
-                    </a:p>
-                  </a:txBody>
-                  <a:tcPr/>
-                </a:tc>
-                <a:tc>
-                  <a:txBody>
-                    <a:bodyPr/>
-                    <a:lstStyle/>
-                    <a:p>
-                      <a:pPr>
-                        <a:defRPr sz="900"/>
-                      </a:pPr>
-                      <a:r>
-                        <a:t>—</a:t>
-                      </a:r>
-                    </a:p>
-                  </a:txBody>
-                  <a:tcPr/>
-                </a:tc>
-                <a:tc>
-                  <a:txBody>
-                    <a:bodyPr/>
-                    <a:lstStyle/>
-                    <a:p>
-                      <a:pPr>
-                        <a:defRPr sz="900"/>
-                      </a:pPr>
-                      <a:r>
-                        <a:t>—</a:t>
-                      </a:r>
-                    </a:p>
-                  </a:txBody>
-                  <a:tcPr/>
-                </a:tc>
-                <a:tc>
-                  <a:txBody>
-                    <a:bodyPr/>
-                    <a:lstStyle/>
-                    <a:p>
-                      <a:pPr>
-                        <a:defRPr sz="900"/>
-                      </a:pPr>
-                      <a:r>
-                        <a:t>+64</a:t>
-                      </a:r>
-                    </a:p>
-                  </a:txBody>
-                  <a:tcPr/>
-                </a:tc>
-                <a:tc>
-                  <a:txBody>
-                    <a:bodyPr/>
-                    <a:lstStyle/>
-                    <a:p>
-                      <a:pPr>
-                        <a:defRPr sz="900"/>
-                      </a:pPr>
-                      <a:r>
-                        <a:t>—</a:t>
-                      </a:r>
-                    </a:p>
-                  </a:txBody>
-                  <a:tcPr/>
-                </a:tc>
-                <a:tc>
-                  <a:txBody>
-                    <a:bodyPr/>
-                    <a:lstStyle/>
-                    <a:p>
-                      <a:pPr>
-                        <a:defRPr sz="900"/>
-                      </a:pPr>
-                      <a:r>
-                        <a:t>(+65.2, 30)</a:t>
-                      </a:r>
-                    </a:p>
-                  </a:txBody>
-                  <a:tcPr/>
-                </a:tc>
-                <a:tc>
-                  <a:txBody>
-                    <a:bodyPr/>
-                    <a:lstStyle/>
-                    <a:p>
-                      <a:pPr>
-                        <a:defRPr sz="900"/>
-                      </a:pPr>
-                      <a:r>
-                        <a:t>—</a:t>
-                      </a:r>
-                    </a:p>
-                  </a:txBody>
-                  <a:tcPr/>
-                </a:tc>
-              </a:tr>
-              <a:tr h="337185">
-                <a:tc>
-                  <a:txBody>
-                    <a:bodyPr/>
-                    <a:lstStyle/>
-                    <a:p>
-                      <a:pPr>
-                        <a:defRPr sz="900" b="1"/>
-                      </a:pPr>
-                      <a:r>
-                        <a:t>(+91.9, 33)</a:t>
-                      </a:r>
-                    </a:p>
-                  </a:txBody>
-                  <a:tcPr/>
-                </a:tc>
-                <a:tc>
-                  <a:txBody>
-                    <a:bodyPr/>
-                    <a:lstStyle/>
-                    <a:p>
-                      <a:pPr>
-                        <a:defRPr sz="900"/>
-                      </a:pPr>
-                      <a:r>
-                        <a:t>—</a:t>
-                      </a:r>
-                    </a:p>
-                  </a:txBody>
-                  <a:tcPr/>
-                </a:tc>
-                <a:tc>
-                  <a:txBody>
-                    <a:bodyPr/>
-                    <a:lstStyle/>
-                    <a:p>
-                      <a:pPr>
-                        <a:defRPr sz="900"/>
-                      </a:pPr>
-                      <a:r>
-                        <a:t>—</a:t>
-                      </a:r>
-                    </a:p>
-                  </a:txBody>
-                  <a:tcPr/>
-                </a:tc>
-                <a:tc>
-                  <a:txBody>
-                    <a:bodyPr/>
-                    <a:lstStyle/>
-                    <a:p>
-                      <a:pPr>
-                        <a:defRPr sz="900"/>
-                      </a:pPr>
-                      <a:r>
-                        <a:t>—</a:t>
-                      </a:r>
-                    </a:p>
-                  </a:txBody>
-                  <a:tcPr/>
-                </a:tc>
-                <a:tc>
-                  <a:txBody>
-                    <a:bodyPr/>
-                    <a:lstStyle/>
-                    <a:p>
-                      <a:pPr>
-                        <a:defRPr sz="900"/>
-                      </a:pPr>
-                      <a:r>
-                        <a:t>+92</a:t>
-                      </a:r>
-                    </a:p>
-                  </a:txBody>
-                  <a:tcPr/>
-                </a:tc>
-                <a:tc>
-                  <a:txBody>
-                    <a:bodyPr/>
-                    <a:lstStyle/>
-                    <a:p>
-                      <a:pPr>
-                        <a:defRPr sz="900"/>
-                      </a:pPr>
-                      <a:r>
-                        <a:t>—</a:t>
-                      </a:r>
-                    </a:p>
-                  </a:txBody>
-                  <a:tcPr/>
-                </a:tc>
-                <a:tc>
-                  <a:txBody>
-                    <a:bodyPr/>
-                    <a:lstStyle/>
-                    <a:p>
-                      <a:pPr>
-                        <a:defRPr sz="900"/>
-                      </a:pPr>
-                      <a:r>
-                        <a:t>(+91.2, 36)</a:t>
-                      </a:r>
-                    </a:p>
-                  </a:txBody>
-                  <a:tcPr/>
-                </a:tc>
-                <a:tc>
-                  <a:txBody>
-                    <a:bodyPr/>
-                    <a:lstStyle/>
-                    <a:p>
-                      <a:pPr>
-                        <a:defRPr sz="900"/>
-                      </a:pPr>
-                      <a:r>
-                        <a:t>—</a:t>
-                      </a:r>
-                    </a:p>
-                  </a:txBody>
-                  <a:tcPr/>
-                </a:tc>
-              </a:tr>
-              <a:tr h="337185">
-                <a:tc>
-                  <a:txBody>
-                    <a:bodyPr/>
-                    <a:lstStyle/>
-                    <a:p>
-                      <a:pPr>
-                        <a:defRPr sz="900" b="1"/>
-                      </a:pPr>
-                      <a:r>
-                        <a:t>(+114.4, 24)</a:t>
-                      </a:r>
-                    </a:p>
-                  </a:txBody>
-                  <a:tcPr/>
-                </a:tc>
-                <a:tc>
-                  <a:txBody>
-                    <a:bodyPr/>
-                    <a:lstStyle/>
-                    <a:p>
-                      <a:pPr>
-                        <a:defRPr sz="900"/>
-                      </a:pPr>
-                      <a:r>
-                        <a:t>—</a:t>
-                      </a:r>
-                    </a:p>
-                  </a:txBody>
-                  <a:tcPr/>
-                </a:tc>
-                <a:tc>
-                  <a:txBody>
-                    <a:bodyPr/>
-                    <a:lstStyle/>
-                    <a:p>
-                      <a:pPr>
-                        <a:defRPr sz="900"/>
-                      </a:pPr>
-                      <a:r>
-                        <a:t>—</a:t>
-                      </a:r>
-                    </a:p>
-                  </a:txBody>
-                  <a:tcPr/>
-                </a:tc>
-                <a:tc>
-                  <a:txBody>
-                    <a:bodyPr/>
-                    <a:lstStyle/>
-                    <a:p>
-                      <a:pPr>
-                        <a:defRPr sz="900"/>
-                      </a:pPr>
-                      <a:r>
-                        <a:t>—</a:t>
-                      </a:r>
-                    </a:p>
-                  </a:txBody>
-                  <a:tcPr/>
-                </a:tc>
-                <a:tc>
-                  <a:txBody>
-                    <a:bodyPr/>
-                    <a:lstStyle/>
-                    <a:p>
-                      <a:pPr>
-                        <a:defRPr sz="900"/>
-                      </a:pPr>
-                      <a:r>
-                        <a:t>+116</a:t>
-                      </a:r>
-                    </a:p>
-                  </a:txBody>
-                  <a:tcPr/>
-                </a:tc>
-                <a:tc>
-                  <a:txBody>
-                    <a:bodyPr/>
-                    <a:lstStyle/>
-                    <a:p>
-                      <a:pPr>
-                        <a:defRPr sz="900"/>
-                      </a:pPr>
-                      <a:r>
-                        <a:t>—</a:t>
-                      </a:r>
-                    </a:p>
-                  </a:txBody>
-                  <a:tcPr/>
-                </a:tc>
-                <a:tc>
-                  <a:txBody>
-                    <a:bodyPr/>
-                    <a:lstStyle/>
-                    <a:p>
-                      <a:pPr>
-                        <a:defRPr sz="900"/>
-                      </a:pPr>
-                      <a:r>
-                        <a:t>—</a:t>
-                      </a:r>
-                    </a:p>
-                  </a:txBody>
-                  <a:tcPr/>
-                </a:tc>
-                <a:tc>
-                  <a:txBody>
-                    <a:bodyPr/>
-                    <a:lstStyle/>
-                    <a:p>
-                      <a:pPr>
-                        <a:defRPr sz="900"/>
-                      </a:pPr>
-                      <a:r>
-                        <a:t>—</a:t>
-                      </a:r>
-                    </a:p>
-                  </a:txBody>
-                  <a:tcPr/>
-                </a:tc>
-              </a:tr>
-              <a:tr h="337185">
-                <a:tc>
-                  <a:txBody>
-                    <a:bodyPr/>
-                    <a:lstStyle/>
-                    <a:p>
-                      <a:pPr>
-                        <a:defRPr sz="900" b="1"/>
-                      </a:pPr>
-                      <a:r>
-                        <a:t>후보 (−34?)</a:t>
-                      </a:r>
-                    </a:p>
-                  </a:txBody>
-                  <a:tcPr/>
-                </a:tc>
-                <a:tc>
-                  <a:txBody>
-                    <a:bodyPr/>
-                    <a:lstStyle/>
-                    <a:p>
-                      <a:pPr>
-                        <a:defRPr sz="900"/>
-                      </a:pPr>
-                      <a:r>
-                        <a:t>(−38, 37)?</a:t>
-                      </a:r>
-                    </a:p>
-                  </a:txBody>
-                  <a:tcPr/>
-                </a:tc>
-                <a:tc>
-                  <a:txBody>
-                    <a:bodyPr/>
-                    <a:lstStyle/>
-                    <a:p>
-                      <a:pPr>
-                        <a:defRPr sz="900"/>
-                      </a:pPr>
-                      <a:r>
-                        <a:t>−34</a:t>
-                      </a:r>
-                    </a:p>
-                  </a:txBody>
-                  <a:tcPr/>
-                </a:tc>
-                <a:tc>
-                  <a:txBody>
-                    <a:bodyPr/>
-                    <a:lstStyle/>
-                    <a:p>
-                      <a:pPr>
-                        <a:defRPr sz="900"/>
-                      </a:pPr>
-                      <a:r>
-                        <a:t>−30</a:t>
-                      </a:r>
-                    </a:p>
-                  </a:txBody>
-                  <a:tcPr/>
-                </a:tc>
-                <a:tc>
-                  <a:txBody>
-                    <a:bodyPr/>
-                    <a:lstStyle/>
-                    <a:p>
-                      <a:pPr>
-                        <a:defRPr sz="900"/>
-                      </a:pPr>
-                      <a:r>
-                        <a:t>—</a:t>
-                      </a:r>
-                    </a:p>
-                  </a:txBody>
-                  <a:tcPr/>
-                </a:tc>
-                <a:tc>
-                  <a:txBody>
-                    <a:bodyPr/>
-                    <a:lstStyle/>
-                    <a:p>
-                      <a:pPr>
-                        <a:defRPr sz="900"/>
-                      </a:pPr>
-                      <a:r>
-                        <a:t>(−34.4, 17)</a:t>
-                      </a:r>
-                    </a:p>
-                  </a:txBody>
-                  <a:tcPr/>
-                </a:tc>
-                <a:tc>
-                  <a:txBody>
-                    <a:bodyPr/>
-                    <a:lstStyle/>
-                    <a:p>
-                      <a:pPr>
-                        <a:defRPr sz="900"/>
-                      </a:pPr>
-                      <a:r>
-                        <a:t>—</a:t>
-                      </a:r>
-                    </a:p>
-                  </a:txBody>
-                  <a:tcPr/>
-                </a:tc>
-                <a:tc>
-                  <a:txBody>
-                    <a:bodyPr/>
-                    <a:lstStyle/>
-                    <a:p>
-                      <a:pPr>
-                        <a:defRPr sz="900"/>
-                      </a:pPr>
-                      <a:r>
-                        <a:t>—</a:t>
-                      </a:r>
-                    </a:p>
-                  </a:txBody>
-                  <a:tcPr/>
-                </a:tc>
-              </a:tr>
-            </a:tbl>
-          </a:graphicData>
-        </a:graphic>
-      </p:graphicFrame>
     </p:spTree>
   </p:cSld>
   <p:clrMapOvr>

</xml_diff>